<commit_message>
Add EcomBunch logo branding to onboarding presentation
Co-Authored-By: Claude Fable 5 <noreply@anthropic.com>
Claude-Session: https://claude.ai/code/session_01SYdwZ3ZUaXCRie1dKGpAUA
</commit_message>
<xml_diff>
--- a/presentations/EcomBunch-Client-Onboarding.pptx
+++ b/presentations/EcomBunch-Client-Onboarding.pptx
@@ -1716,29 +1716,9 @@
           <a:ln/>
         </p:spPr>
       </p:sp>
-      <p:sp>
-        <p:nvSpPr>
-          <p:cNvPr id="4" name="Shape 2"/>
-          <p:cNvSpPr/>
-          <p:nvPr/>
-        </p:nvSpPr>
-        <p:spPr>
-          <a:xfrm>
-            <a:off x="822960" y="822960"/>
-            <a:ext cx="914400" cy="914400"/>
-          </a:xfrm>
-          <a:prstGeom prst="ellipse">
-            <a:avLst/>
-          </a:prstGeom>
-          <a:solidFill>
-            <a:srgbClr val="F96167"/>
-          </a:solidFill>
-          <a:ln/>
-        </p:spPr>
-      </p:sp>
       <p:pic>
         <p:nvPicPr>
-          <p:cNvPr id="5" name="Image 0" descr="preencoded.png">    </p:cNvPr>
+          <p:cNvPr id="4" name="Image 0" descr="preencoded.png">    </p:cNvPr>
           <p:cNvPicPr>
             <a:picLocks noChangeAspect="1"/>
           </p:cNvPicPr>
@@ -1752,8 +1732,8 @@
         </p:blipFill>
         <p:spPr>
           <a:xfrm>
-            <a:off x="1060704" y="1060704"/>
-            <a:ext cx="438912" cy="438912"/>
+            <a:off x="685800" y="777240"/>
+            <a:ext cx="4754880" cy="1280160"/>
           </a:xfrm>
           <a:prstGeom prst="rect">
             <a:avLst/>
@@ -1762,46 +1742,7 @@
       </p:pic>
       <p:sp>
         <p:nvSpPr>
-          <p:cNvPr id="6" name="Text 3"/>
-          <p:cNvSpPr/>
-          <p:nvPr/>
-        </p:nvSpPr>
-        <p:spPr>
-          <a:xfrm>
-            <a:off x="822960" y="2148840"/>
-            <a:ext cx="10515600" cy="457200"/>
-          </a:xfrm>
-          <a:prstGeom prst="rect">
-            <a:avLst/>
-          </a:prstGeom>
-          <a:noFill/>
-          <a:ln/>
-        </p:spPr>
-        <p:txBody>
-          <a:bodyPr wrap="square" lIns="0" tIns="0" rIns="0" bIns="0" rtlCol="0" anchor="ctr"/>
-          <a:lstStyle/>
-          <a:p>
-            <a:pPr indent="0" marL="0">
-              <a:buNone/>
-            </a:pPr>
-            <a:r>
-              <a:rPr lang="en-US" sz="1800" b="1" spc="600" kern="0" dirty="0">
-                <a:solidFill>
-                  <a:srgbClr val="CADCFC"/>
-                </a:solidFill>
-                <a:latin typeface="Calibri" pitchFamily="34" charset="0"/>
-                <a:ea typeface="Calibri" pitchFamily="34" charset="-122"/>
-                <a:cs typeface="Calibri" pitchFamily="34" charset="-120"/>
-              </a:rPr>
-              <a:t>ECOMBUNCH</a:t>
-            </a:r>
-            <a:endParaRPr lang="en-US" sz="1800" dirty="0"/>
-          </a:p>
-        </p:txBody>
-      </p:sp>
-      <p:sp>
-        <p:nvSpPr>
-          <p:cNvPr id="7" name="Text 4"/>
+          <p:cNvPr id="5" name="Text 2"/>
           <p:cNvSpPr/>
           <p:nvPr/>
         </p:nvSpPr>
@@ -1840,7 +1781,7 @@
       </p:sp>
       <p:sp>
         <p:nvSpPr>
-          <p:cNvPr id="8" name="Text 5"/>
+          <p:cNvPr id="6" name="Text 3"/>
           <p:cNvSpPr/>
           <p:nvPr/>
         </p:nvSpPr>
@@ -1879,7 +1820,7 @@
       </p:sp>
       <p:sp>
         <p:nvSpPr>
-          <p:cNvPr id="9" name="Text 6"/>
+          <p:cNvPr id="7" name="Text 4"/>
           <p:cNvSpPr/>
           <p:nvPr/>
         </p:nvSpPr>
@@ -1918,7 +1859,7 @@
       </p:sp>
       <p:sp>
         <p:nvSpPr>
-          <p:cNvPr id="10" name="Text 7"/>
+          <p:cNvPr id="8" name="Text 5"/>
           <p:cNvSpPr/>
           <p:nvPr/>
         </p:nvSpPr>
@@ -2458,16 +2399,40 @@
           </a:p>
         </p:txBody>
       </p:sp>
-      <p:sp>
-        <p:nvSpPr>
-          <p:cNvPr id="17" name="Text 15"/>
-          <p:cNvSpPr/>
-          <p:nvPr/>
-        </p:nvSpPr>
-        <p:spPr>
-          <a:xfrm>
-            <a:off x="822960" y="5943600"/>
-            <a:ext cx="10058400" cy="457200"/>
+      <p:pic>
+        <p:nvPicPr>
+          <p:cNvPr id="17" name="Image 0" descr="preencoded.png">    </p:cNvPr>
+          <p:cNvPicPr>
+            <a:picLocks noChangeAspect="1"/>
+          </p:cNvPicPr>
+          <p:nvPr/>
+        </p:nvPicPr>
+        <p:blipFill>
+          <a:blip r:embed="rId1"/>
+          <a:stretch>
+            <a:fillRect/>
+          </a:stretch>
+        </p:blipFill>
+        <p:spPr>
+          <a:xfrm>
+            <a:off x="822960" y="5623560"/>
+            <a:ext cx="3108960" cy="841248"/>
+          </a:xfrm>
+          <a:prstGeom prst="rect">
+            <a:avLst/>
+          </a:prstGeom>
+        </p:spPr>
+      </p:pic>
+      <p:sp>
+        <p:nvSpPr>
+          <p:cNvPr id="18" name="Text 15"/>
+          <p:cNvSpPr/>
+          <p:nvPr/>
+        </p:nvSpPr>
+        <p:spPr>
+          <a:xfrm>
+            <a:off x="4206240" y="5852160"/>
+            <a:ext cx="7589520" cy="457200"/>
           </a:xfrm>
           <a:prstGeom prst="rect">
             <a:avLst/>
@@ -2483,7 +2448,7 @@
               <a:buNone/>
             </a:pPr>
             <a:r>
-              <a:rPr lang="en-US" sz="1400" i="1" dirty="0">
+              <a:rPr lang="en-US" sz="1300" i="1" dirty="0">
                 <a:solidFill>
                   <a:srgbClr val="CADCFC"/>
                 </a:solidFill>
@@ -2491,9 +2456,9 @@
                 <a:ea typeface="Calibri" pitchFamily="34" charset="-122"/>
                 <a:cs typeface="Calibri" pitchFamily="34" charset="-120"/>
               </a:rPr>
-              <a:t>EcomBunch — built to onboard, launch, and scale US ecommerce clients.</a:t>
-            </a:r>
-            <a:endParaRPr lang="en-US" sz="1400" dirty="0"/>
+              <a:t>Built to onboard, launch, and scale US ecommerce clients.</a:t>
+            </a:r>
+            <a:endParaRPr lang="en-US" sz="1300" dirty="0"/>
           </a:p>
         </p:txBody>
       </p:sp>
@@ -2529,16 +2494,40 @@
           <a:chExt cx="0" cy="0"/>
         </a:xfrm>
       </p:grpSpPr>
-      <p:sp>
-        <p:nvSpPr>
-          <p:cNvPr id="2" name="Text 0"/>
+      <p:pic>
+        <p:nvPicPr>
+          <p:cNvPr id="2" name="Image 0" descr="preencoded.png">    </p:cNvPr>
+          <p:cNvPicPr>
+            <a:picLocks noChangeAspect="1"/>
+          </p:cNvPicPr>
+          <p:nvPr/>
+        </p:nvPicPr>
+        <p:blipFill>
+          <a:blip r:embed="rId1"/>
+          <a:stretch>
+            <a:fillRect/>
+          </a:stretch>
+        </p:blipFill>
+        <p:spPr>
+          <a:xfrm>
+            <a:off x="9720072" y="384048"/>
+            <a:ext cx="1920240" cy="521208"/>
+          </a:xfrm>
+          <a:prstGeom prst="rect">
+            <a:avLst/>
+          </a:prstGeom>
+        </p:spPr>
+      </p:pic>
+      <p:sp>
+        <p:nvSpPr>
+          <p:cNvPr id="3" name="Text 0"/>
           <p:cNvSpPr/>
           <p:nvPr/>
         </p:nvSpPr>
         <p:spPr>
           <a:xfrm>
             <a:off x="548640" y="320040"/>
-            <a:ext cx="11064240" cy="685800"/>
+            <a:ext cx="9052560" cy="685800"/>
           </a:xfrm>
           <a:prstGeom prst="rect">
             <a:avLst/>
@@ -2570,7 +2559,7 @@
       </p:sp>
       <p:sp>
         <p:nvSpPr>
-          <p:cNvPr id="3" name="Text 1"/>
+          <p:cNvPr id="4" name="Text 1"/>
           <p:cNvSpPr/>
           <p:nvPr/>
         </p:nvSpPr>
@@ -2609,7 +2598,7 @@
       </p:sp>
       <p:sp>
         <p:nvSpPr>
-          <p:cNvPr id="4" name="Shape 2"/>
+          <p:cNvPr id="5" name="Shape 2"/>
           <p:cNvSpPr/>
           <p:nvPr/>
         </p:nvSpPr>
@@ -2638,7 +2627,7 @@
       </p:sp>
       <p:sp>
         <p:nvSpPr>
-          <p:cNvPr id="5" name="Shape 3"/>
+          <p:cNvPr id="6" name="Shape 3"/>
           <p:cNvSpPr/>
           <p:nvPr/>
         </p:nvSpPr>
@@ -2658,14 +2647,14 @@
       </p:sp>
       <p:pic>
         <p:nvPicPr>
-          <p:cNvPr id="6" name="Image 0" descr="preencoded.png">    </p:cNvPr>
+          <p:cNvPr id="7" name="Image 1" descr="preencoded.png">    </p:cNvPr>
           <p:cNvPicPr>
             <a:picLocks noChangeAspect="1"/>
           </p:cNvPicPr>
           <p:nvPr/>
         </p:nvPicPr>
         <p:blipFill>
-          <a:blip r:embed="rId1"/>
+          <a:blip r:embed="rId2"/>
           <a:stretch>
             <a:fillRect/>
           </a:stretch>
@@ -2682,7 +2671,7 @@
       </p:pic>
       <p:sp>
         <p:nvSpPr>
-          <p:cNvPr id="7" name="Text 4"/>
+          <p:cNvPr id="8" name="Text 4"/>
           <p:cNvSpPr/>
           <p:nvPr/>
         </p:nvSpPr>
@@ -2721,7 +2710,7 @@
       </p:sp>
       <p:sp>
         <p:nvSpPr>
-          <p:cNvPr id="8" name="Text 5"/>
+          <p:cNvPr id="9" name="Text 5"/>
           <p:cNvSpPr/>
           <p:nvPr/>
         </p:nvSpPr>
@@ -2760,7 +2749,7 @@
       </p:sp>
       <p:sp>
         <p:nvSpPr>
-          <p:cNvPr id="9" name="Text 6"/>
+          <p:cNvPr id="10" name="Text 6"/>
           <p:cNvSpPr/>
           <p:nvPr/>
         </p:nvSpPr>
@@ -2799,7 +2788,7 @@
       </p:sp>
       <p:sp>
         <p:nvSpPr>
-          <p:cNvPr id="10" name="Shape 7"/>
+          <p:cNvPr id="11" name="Shape 7"/>
           <p:cNvSpPr/>
           <p:nvPr/>
         </p:nvSpPr>
@@ -2828,7 +2817,7 @@
       </p:sp>
       <p:sp>
         <p:nvSpPr>
-          <p:cNvPr id="11" name="Shape 8"/>
+          <p:cNvPr id="12" name="Shape 8"/>
           <p:cNvSpPr/>
           <p:nvPr/>
         </p:nvSpPr>
@@ -2848,14 +2837,14 @@
       </p:sp>
       <p:pic>
         <p:nvPicPr>
-          <p:cNvPr id="12" name="Image 1" descr="preencoded.png">    </p:cNvPr>
+          <p:cNvPr id="13" name="Image 2" descr="preencoded.png">    </p:cNvPr>
           <p:cNvPicPr>
             <a:picLocks noChangeAspect="1"/>
           </p:cNvPicPr>
           <p:nvPr/>
         </p:nvPicPr>
         <p:blipFill>
-          <a:blip r:embed="rId2"/>
+          <a:blip r:embed="rId3"/>
           <a:stretch>
             <a:fillRect/>
           </a:stretch>
@@ -2872,7 +2861,7 @@
       </p:pic>
       <p:sp>
         <p:nvSpPr>
-          <p:cNvPr id="13" name="Text 9"/>
+          <p:cNvPr id="14" name="Text 9"/>
           <p:cNvSpPr/>
           <p:nvPr/>
         </p:nvSpPr>
@@ -2911,7 +2900,7 @@
       </p:sp>
       <p:sp>
         <p:nvSpPr>
-          <p:cNvPr id="14" name="Text 10"/>
+          <p:cNvPr id="15" name="Text 10"/>
           <p:cNvSpPr/>
           <p:nvPr/>
         </p:nvSpPr>
@@ -2950,7 +2939,7 @@
       </p:sp>
       <p:sp>
         <p:nvSpPr>
-          <p:cNvPr id="15" name="Text 11"/>
+          <p:cNvPr id="16" name="Text 11"/>
           <p:cNvSpPr/>
           <p:nvPr/>
         </p:nvSpPr>
@@ -2989,7 +2978,7 @@
       </p:sp>
       <p:sp>
         <p:nvSpPr>
-          <p:cNvPr id="16" name="Shape 12"/>
+          <p:cNvPr id="17" name="Shape 12"/>
           <p:cNvSpPr/>
           <p:nvPr/>
         </p:nvSpPr>
@@ -3018,7 +3007,7 @@
       </p:sp>
       <p:sp>
         <p:nvSpPr>
-          <p:cNvPr id="17" name="Shape 13"/>
+          <p:cNvPr id="18" name="Shape 13"/>
           <p:cNvSpPr/>
           <p:nvPr/>
         </p:nvSpPr>
@@ -3038,14 +3027,14 @@
       </p:sp>
       <p:pic>
         <p:nvPicPr>
-          <p:cNvPr id="18" name="Image 2" descr="preencoded.png">    </p:cNvPr>
+          <p:cNvPr id="19" name="Image 3" descr="preencoded.png">    </p:cNvPr>
           <p:cNvPicPr>
             <a:picLocks noChangeAspect="1"/>
           </p:cNvPicPr>
           <p:nvPr/>
         </p:nvPicPr>
         <p:blipFill>
-          <a:blip r:embed="rId3"/>
+          <a:blip r:embed="rId4"/>
           <a:stretch>
             <a:fillRect/>
           </a:stretch>
@@ -3062,7 +3051,7 @@
       </p:pic>
       <p:sp>
         <p:nvSpPr>
-          <p:cNvPr id="19" name="Text 14"/>
+          <p:cNvPr id="20" name="Text 14"/>
           <p:cNvSpPr/>
           <p:nvPr/>
         </p:nvSpPr>
@@ -3101,7 +3090,7 @@
       </p:sp>
       <p:sp>
         <p:nvSpPr>
-          <p:cNvPr id="20" name="Text 15"/>
+          <p:cNvPr id="21" name="Text 15"/>
           <p:cNvSpPr/>
           <p:nvPr/>
         </p:nvSpPr>
@@ -3140,7 +3129,7 @@
       </p:sp>
       <p:sp>
         <p:nvSpPr>
-          <p:cNvPr id="21" name="Text 16"/>
+          <p:cNvPr id="22" name="Text 16"/>
           <p:cNvSpPr/>
           <p:nvPr/>
         </p:nvSpPr>
@@ -3179,7 +3168,7 @@
       </p:sp>
       <p:sp>
         <p:nvSpPr>
-          <p:cNvPr id="22" name="Text 17"/>
+          <p:cNvPr id="23" name="Text 17"/>
           <p:cNvSpPr/>
           <p:nvPr/>
         </p:nvSpPr>
@@ -3248,129 +3237,9 @@
           <a:chExt cx="0" cy="0"/>
         </a:xfrm>
       </p:grpSpPr>
-      <p:sp>
-        <p:nvSpPr>
-          <p:cNvPr id="2" name="Text 0"/>
-          <p:cNvSpPr/>
-          <p:nvPr/>
-        </p:nvSpPr>
-        <p:spPr>
-          <a:xfrm>
-            <a:off x="548640" y="320040"/>
-            <a:ext cx="11064240" cy="685800"/>
-          </a:xfrm>
-          <a:prstGeom prst="rect">
-            <a:avLst/>
-          </a:prstGeom>
-          <a:noFill/>
-          <a:ln/>
-        </p:spPr>
-        <p:txBody>
-          <a:bodyPr wrap="square" lIns="0" tIns="0" rIns="0" bIns="0" rtlCol="0" anchor="ctr"/>
-          <a:lstStyle/>
-          <a:p>
-            <a:pPr indent="0" marL="0">
-              <a:buNone/>
-            </a:pPr>
-            <a:r>
-              <a:rPr lang="en-US" sz="3200" b="1" dirty="0">
-                <a:solidFill>
-                  <a:srgbClr val="1E2761"/>
-                </a:solidFill>
-                <a:latin typeface="Cambria" pitchFamily="34" charset="0"/>
-                <a:ea typeface="Cambria" pitchFamily="34" charset="-122"/>
-                <a:cs typeface="Cambria" pitchFamily="34" charset="-120"/>
-              </a:rPr>
-              <a:t>Universal Onboarding Flow</a:t>
-            </a:r>
-            <a:endParaRPr lang="en-US" sz="3200" dirty="0"/>
-          </a:p>
-        </p:txBody>
-      </p:sp>
-      <p:sp>
-        <p:nvSpPr>
-          <p:cNvPr id="3" name="Text 1"/>
-          <p:cNvSpPr/>
-          <p:nvPr/>
-        </p:nvSpPr>
-        <p:spPr>
-          <a:xfrm>
-            <a:off x="548640" y="960120"/>
-            <a:ext cx="11064240" cy="365760"/>
-          </a:xfrm>
-          <a:prstGeom prst="rect">
-            <a:avLst/>
-          </a:prstGeom>
-          <a:noFill/>
-          <a:ln/>
-        </p:spPr>
-        <p:txBody>
-          <a:bodyPr wrap="square" lIns="0" tIns="0" rIns="0" bIns="0" rtlCol="0" anchor="ctr"/>
-          <a:lstStyle/>
-          <a:p>
-            <a:pPr indent="0" marL="0">
-              <a:buNone/>
-            </a:pPr>
-            <a:r>
-              <a:rPr lang="en-US" sz="1400" i="1" dirty="0">
-                <a:solidFill>
-                  <a:srgbClr val="5A6285"/>
-                </a:solidFill>
-                <a:latin typeface="Calibri" pitchFamily="34" charset="0"/>
-                <a:ea typeface="Calibri" pitchFamily="34" charset="-122"/>
-                <a:cs typeface="Calibri" pitchFamily="34" charset="-120"/>
-              </a:rPr>
-              <a:t>The same 6 steps for every client, regardless of model — target: live within 30 days</a:t>
-            </a:r>
-            <a:endParaRPr lang="en-US" sz="1400" dirty="0"/>
-          </a:p>
-        </p:txBody>
-      </p:sp>
-      <p:sp>
-        <p:nvSpPr>
-          <p:cNvPr id="4" name="Shape 2"/>
-          <p:cNvSpPr/>
-          <p:nvPr/>
-        </p:nvSpPr>
-        <p:spPr>
-          <a:xfrm>
-            <a:off x="288036" y="1645920"/>
-            <a:ext cx="3657600" cy="1481328"/>
-          </a:xfrm>
-          <a:prstGeom prst="roundRect">
-            <a:avLst>
-              <a:gd name="adj" fmla="val 6173"/>
-            </a:avLst>
-          </a:prstGeom>
-          <a:solidFill>
-            <a:srgbClr val="F4F7FE"/>
-          </a:solidFill>
-          <a:ln/>
-        </p:spPr>
-      </p:sp>
-      <p:sp>
-        <p:nvSpPr>
-          <p:cNvPr id="5" name="Shape 3"/>
-          <p:cNvSpPr/>
-          <p:nvPr/>
-        </p:nvSpPr>
-        <p:spPr>
-          <a:xfrm>
-            <a:off x="489204" y="1865376"/>
-            <a:ext cx="566928" cy="566928"/>
-          </a:xfrm>
-          <a:prstGeom prst="ellipse">
-            <a:avLst/>
-          </a:prstGeom>
-          <a:solidFill>
-            <a:srgbClr val="1E2761"/>
-          </a:solidFill>
-          <a:ln/>
-        </p:spPr>
-      </p:sp>
       <p:pic>
         <p:nvPicPr>
-          <p:cNvPr id="6" name="Image 0" descr="preencoded.png">    </p:cNvPr>
+          <p:cNvPr id="2" name="Image 0" descr="preencoded.png">    </p:cNvPr>
           <p:cNvPicPr>
             <a:picLocks noChangeAspect="1"/>
           </p:cNvPicPr>
@@ -3384,8 +3253,8 @@
         </p:blipFill>
         <p:spPr>
           <a:xfrm>
-            <a:off x="636605" y="2012777"/>
-            <a:ext cx="272125" cy="272125"/>
+            <a:off x="9720072" y="384048"/>
+            <a:ext cx="1920240" cy="521208"/>
           </a:xfrm>
           <a:prstGeom prst="rect">
             <a:avLst/>
@@ -3394,14 +3263,14 @@
       </p:pic>
       <p:sp>
         <p:nvSpPr>
-          <p:cNvPr id="7" name="Text 4"/>
-          <p:cNvSpPr/>
-          <p:nvPr/>
-        </p:nvSpPr>
-        <p:spPr>
-          <a:xfrm>
-            <a:off x="1202436" y="1792224"/>
-            <a:ext cx="2606040" cy="320040"/>
+          <p:cNvPr id="3" name="Text 0"/>
+          <p:cNvSpPr/>
+          <p:nvPr/>
+        </p:nvSpPr>
+        <p:spPr>
+          <a:xfrm>
+            <a:off x="548640" y="320040"/>
+            <a:ext cx="9052560" cy="685800"/>
           </a:xfrm>
           <a:prstGeom prst="rect">
             <a:avLst/>
@@ -3417,30 +3286,30 @@
               <a:buNone/>
             </a:pPr>
             <a:r>
-              <a:rPr lang="en-US" sz="1500" b="1" dirty="0">
+              <a:rPr lang="en-US" sz="3200" b="1" dirty="0">
                 <a:solidFill>
                   <a:srgbClr val="1E2761"/>
                 </a:solidFill>
-                <a:latin typeface="Calibri" pitchFamily="34" charset="0"/>
-                <a:ea typeface="Calibri" pitchFamily="34" charset="-122"/>
-                <a:cs typeface="Calibri" pitchFamily="34" charset="-120"/>
-              </a:rPr>
-              <a:t>1. Kickoff</a:t>
-            </a:r>
-            <a:endParaRPr lang="en-US" sz="1500" dirty="0"/>
-          </a:p>
-        </p:txBody>
-      </p:sp>
-      <p:sp>
-        <p:nvSpPr>
-          <p:cNvPr id="8" name="Text 5"/>
-          <p:cNvSpPr/>
-          <p:nvPr/>
-        </p:nvSpPr>
-        <p:spPr>
-          <a:xfrm>
-            <a:off x="1202436" y="2121408"/>
-            <a:ext cx="2606040" cy="914400"/>
+                <a:latin typeface="Cambria" pitchFamily="34" charset="0"/>
+                <a:ea typeface="Cambria" pitchFamily="34" charset="-122"/>
+                <a:cs typeface="Cambria" pitchFamily="34" charset="-120"/>
+              </a:rPr>
+              <a:t>Universal Onboarding Flow</a:t>
+            </a:r>
+            <a:endParaRPr lang="en-US" sz="3200" dirty="0"/>
+          </a:p>
+        </p:txBody>
+      </p:sp>
+      <p:sp>
+        <p:nvSpPr>
+          <p:cNvPr id="4" name="Text 1"/>
+          <p:cNvSpPr/>
+          <p:nvPr/>
+        </p:nvSpPr>
+        <p:spPr>
+          <a:xfrm>
+            <a:off x="548640" y="960120"/>
+            <a:ext cx="11064240" cy="365760"/>
           </a:xfrm>
           <a:prstGeom prst="rect">
             <a:avLst/>
@@ -3456,29 +3325,29 @@
               <a:buNone/>
             </a:pPr>
             <a:r>
-              <a:rPr lang="en-US" sz="1050" dirty="0">
-                <a:solidFill>
-                  <a:srgbClr val="22284A"/>
-                </a:solidFill>
-                <a:latin typeface="Calibri" pitchFamily="34" charset="0"/>
-                <a:ea typeface="Calibri" pitchFamily="34" charset="-122"/>
-                <a:cs typeface="Calibri" pitchFamily="34" charset="-120"/>
-              </a:rPr>
-              <a:t>Welcome email + kickoff call within 48 hrs. Intake form: goals, budget, timezone, decision-maker.</a:t>
-            </a:r>
-            <a:endParaRPr lang="en-US" sz="1050" dirty="0"/>
-          </a:p>
-        </p:txBody>
-      </p:sp>
-      <p:sp>
-        <p:nvSpPr>
-          <p:cNvPr id="9" name="Shape 6"/>
-          <p:cNvSpPr/>
-          <p:nvPr/>
-        </p:nvSpPr>
-        <p:spPr>
-          <a:xfrm>
-            <a:off x="4265676" y="1645920"/>
+              <a:rPr lang="en-US" sz="1400" i="1" dirty="0">
+                <a:solidFill>
+                  <a:srgbClr val="5A6285"/>
+                </a:solidFill>
+                <a:latin typeface="Calibri" pitchFamily="34" charset="0"/>
+                <a:ea typeface="Calibri" pitchFamily="34" charset="-122"/>
+                <a:cs typeface="Calibri" pitchFamily="34" charset="-120"/>
+              </a:rPr>
+              <a:t>The same 6 steps for every client, regardless of model — target: live within 30 days</a:t>
+            </a:r>
+            <a:endParaRPr lang="en-US" sz="1400" dirty="0"/>
+          </a:p>
+        </p:txBody>
+      </p:sp>
+      <p:sp>
+        <p:nvSpPr>
+          <p:cNvPr id="5" name="Shape 2"/>
+          <p:cNvSpPr/>
+          <p:nvPr/>
+        </p:nvSpPr>
+        <p:spPr>
+          <a:xfrm>
+            <a:off x="288036" y="1645920"/>
             <a:ext cx="3657600" cy="1481328"/>
           </a:xfrm>
           <a:prstGeom prst="roundRect">
@@ -3494,13 +3363,13 @@
       </p:sp>
       <p:sp>
         <p:nvSpPr>
-          <p:cNvPr id="10" name="Shape 7"/>
-          <p:cNvSpPr/>
-          <p:nvPr/>
-        </p:nvSpPr>
-        <p:spPr>
-          <a:xfrm>
-            <a:off x="4466844" y="1865376"/>
+          <p:cNvPr id="6" name="Shape 3"/>
+          <p:cNvSpPr/>
+          <p:nvPr/>
+        </p:nvSpPr>
+        <p:spPr>
+          <a:xfrm>
+            <a:off x="489204" y="1865376"/>
             <a:ext cx="566928" cy="566928"/>
           </a:xfrm>
           <a:prstGeom prst="ellipse">
@@ -3514,7 +3383,7 @@
       </p:sp>
       <p:pic>
         <p:nvPicPr>
-          <p:cNvPr id="11" name="Image 1" descr="preencoded.png">    </p:cNvPr>
+          <p:cNvPr id="7" name="Image 1" descr="preencoded.png">    </p:cNvPr>
           <p:cNvPicPr>
             <a:picLocks noChangeAspect="1"/>
           </p:cNvPicPr>
@@ -3528,7 +3397,7 @@
         </p:blipFill>
         <p:spPr>
           <a:xfrm>
-            <a:off x="4614245" y="2012777"/>
+            <a:off x="636605" y="2012777"/>
             <a:ext cx="272125" cy="272125"/>
           </a:xfrm>
           <a:prstGeom prst="rect">
@@ -3538,13 +3407,13 @@
       </p:pic>
       <p:sp>
         <p:nvSpPr>
-          <p:cNvPr id="12" name="Text 8"/>
-          <p:cNvSpPr/>
-          <p:nvPr/>
-        </p:nvSpPr>
-        <p:spPr>
-          <a:xfrm>
-            <a:off x="5180076" y="1792224"/>
+          <p:cNvPr id="8" name="Text 4"/>
+          <p:cNvSpPr/>
+          <p:nvPr/>
+        </p:nvSpPr>
+        <p:spPr>
+          <a:xfrm>
+            <a:off x="1202436" y="1792224"/>
             <a:ext cx="2606040" cy="320040"/>
           </a:xfrm>
           <a:prstGeom prst="rect">
@@ -3569,7 +3438,7 @@
                 <a:ea typeface="Calibri" pitchFamily="34" charset="-122"/>
                 <a:cs typeface="Calibri" pitchFamily="34" charset="-120"/>
               </a:rPr>
-              <a:t>2. Contract &amp; Legal</a:t>
+              <a:t>1. Kickoff</a:t>
             </a:r>
             <a:endParaRPr lang="en-US" sz="1500" dirty="0"/>
           </a:p>
@@ -3577,13 +3446,13 @@
       </p:sp>
       <p:sp>
         <p:nvSpPr>
-          <p:cNvPr id="13" name="Text 9"/>
-          <p:cNvSpPr/>
-          <p:nvPr/>
-        </p:nvSpPr>
-        <p:spPr>
-          <a:xfrm>
-            <a:off x="5180076" y="2121408"/>
+          <p:cNvPr id="9" name="Text 5"/>
+          <p:cNvSpPr/>
+          <p:nvPr/>
+        </p:nvSpPr>
+        <p:spPr>
+          <a:xfrm>
+            <a:off x="1202436" y="2121408"/>
             <a:ext cx="2606040" cy="914400"/>
           </a:xfrm>
           <a:prstGeom prst="rect">
@@ -3608,7 +3477,7 @@
                 <a:ea typeface="Calibri" pitchFamily="34" charset="-122"/>
                 <a:cs typeface="Calibri" pitchFamily="34" charset="-120"/>
               </a:rPr>
-              <a:t>Signed agreement / profit-split terms, LLC + EIN check, W-8/W-9 paperwork, NDA if requested.</a:t>
+              <a:t>Welcome email + kickoff call within 48 hrs. Intake form: goals, budget, timezone, decision-maker.</a:t>
             </a:r>
             <a:endParaRPr lang="en-US" sz="1050" dirty="0"/>
           </a:p>
@@ -3616,13 +3485,13 @@
       </p:sp>
       <p:sp>
         <p:nvSpPr>
-          <p:cNvPr id="14" name="Shape 10"/>
-          <p:cNvSpPr/>
-          <p:nvPr/>
-        </p:nvSpPr>
-        <p:spPr>
-          <a:xfrm>
-            <a:off x="8243316" y="1645920"/>
+          <p:cNvPr id="10" name="Shape 6"/>
+          <p:cNvSpPr/>
+          <p:nvPr/>
+        </p:nvSpPr>
+        <p:spPr>
+          <a:xfrm>
+            <a:off x="4265676" y="1645920"/>
             <a:ext cx="3657600" cy="1481328"/>
           </a:xfrm>
           <a:prstGeom prst="roundRect">
@@ -3638,13 +3507,13 @@
       </p:sp>
       <p:sp>
         <p:nvSpPr>
-          <p:cNvPr id="15" name="Shape 11"/>
-          <p:cNvSpPr/>
-          <p:nvPr/>
-        </p:nvSpPr>
-        <p:spPr>
-          <a:xfrm>
-            <a:off x="8444484" y="1865376"/>
+          <p:cNvPr id="11" name="Shape 7"/>
+          <p:cNvSpPr/>
+          <p:nvPr/>
+        </p:nvSpPr>
+        <p:spPr>
+          <a:xfrm>
+            <a:off x="4466844" y="1865376"/>
             <a:ext cx="566928" cy="566928"/>
           </a:xfrm>
           <a:prstGeom prst="ellipse">
@@ -3658,7 +3527,7 @@
       </p:sp>
       <p:pic>
         <p:nvPicPr>
-          <p:cNvPr id="16" name="Image 2" descr="preencoded.png">    </p:cNvPr>
+          <p:cNvPr id="12" name="Image 2" descr="preencoded.png">    </p:cNvPr>
           <p:cNvPicPr>
             <a:picLocks noChangeAspect="1"/>
           </p:cNvPicPr>
@@ -3672,7 +3541,7 @@
         </p:blipFill>
         <p:spPr>
           <a:xfrm>
-            <a:off x="8591885" y="2012777"/>
+            <a:off x="4614245" y="2012777"/>
             <a:ext cx="272125" cy="272125"/>
           </a:xfrm>
           <a:prstGeom prst="rect">
@@ -3682,13 +3551,13 @@
       </p:pic>
       <p:sp>
         <p:nvSpPr>
-          <p:cNvPr id="17" name="Text 12"/>
-          <p:cNvSpPr/>
-          <p:nvPr/>
-        </p:nvSpPr>
-        <p:spPr>
-          <a:xfrm>
-            <a:off x="9157716" y="1792224"/>
+          <p:cNvPr id="13" name="Text 8"/>
+          <p:cNvSpPr/>
+          <p:nvPr/>
+        </p:nvSpPr>
+        <p:spPr>
+          <a:xfrm>
+            <a:off x="5180076" y="1792224"/>
             <a:ext cx="2606040" cy="320040"/>
           </a:xfrm>
           <a:prstGeom prst="rect">
@@ -3713,7 +3582,7 @@
                 <a:ea typeface="Calibri" pitchFamily="34" charset="-122"/>
                 <a:cs typeface="Calibri" pitchFamily="34" charset="-120"/>
               </a:rPr>
-              <a:t>3. Access Setup</a:t>
+              <a:t>2. Contract &amp; Legal</a:t>
             </a:r>
             <a:endParaRPr lang="en-US" sz="1500" dirty="0"/>
           </a:p>
@@ -3721,13 +3590,13 @@
       </p:sp>
       <p:sp>
         <p:nvSpPr>
-          <p:cNvPr id="18" name="Text 13"/>
-          <p:cNvSpPr/>
-          <p:nvPr/>
-        </p:nvSpPr>
-        <p:spPr>
-          <a:xfrm>
-            <a:off x="9157716" y="2121408"/>
+          <p:cNvPr id="14" name="Text 9"/>
+          <p:cNvSpPr/>
+          <p:nvPr/>
+        </p:nvSpPr>
+        <p:spPr>
+          <a:xfrm>
+            <a:off x="5180076" y="2121408"/>
             <a:ext cx="2606040" cy="914400"/>
           </a:xfrm>
           <a:prstGeom prst="rect">
@@ -3752,7 +3621,7 @@
                 <a:ea typeface="Calibri" pitchFamily="34" charset="-122"/>
                 <a:cs typeface="Calibri" pitchFamily="34" charset="-120"/>
               </a:rPr>
-              <a:t>Seller accounts, sourcing accounts, payment (Payoneer / bank), software logins — via secure checklist.</a:t>
+              <a:t>Signed agreement / profit-split terms, LLC + EIN check, W-8/W-9 paperwork, NDA if requested.</a:t>
             </a:r>
             <a:endParaRPr lang="en-US" sz="1050" dirty="0"/>
           </a:p>
@@ -3760,13 +3629,13 @@
       </p:sp>
       <p:sp>
         <p:nvSpPr>
-          <p:cNvPr id="19" name="Shape 14"/>
-          <p:cNvSpPr/>
-          <p:nvPr/>
-        </p:nvSpPr>
-        <p:spPr>
-          <a:xfrm>
-            <a:off x="288036" y="3419856"/>
+          <p:cNvPr id="15" name="Shape 10"/>
+          <p:cNvSpPr/>
+          <p:nvPr/>
+        </p:nvSpPr>
+        <p:spPr>
+          <a:xfrm>
+            <a:off x="8243316" y="1645920"/>
             <a:ext cx="3657600" cy="1481328"/>
           </a:xfrm>
           <a:prstGeom prst="roundRect">
@@ -3775,20 +3644,20 @@
             </a:avLst>
           </a:prstGeom>
           <a:solidFill>
-            <a:srgbClr val="EEF3FF"/>
+            <a:srgbClr val="F4F7FE"/>
           </a:solidFill>
           <a:ln/>
         </p:spPr>
       </p:sp>
       <p:sp>
         <p:nvSpPr>
-          <p:cNvPr id="20" name="Shape 15"/>
-          <p:cNvSpPr/>
-          <p:nvPr/>
-        </p:nvSpPr>
-        <p:spPr>
-          <a:xfrm>
-            <a:off x="489204" y="3639312"/>
+          <p:cNvPr id="16" name="Shape 11"/>
+          <p:cNvSpPr/>
+          <p:nvPr/>
+        </p:nvSpPr>
+        <p:spPr>
+          <a:xfrm>
+            <a:off x="8444484" y="1865376"/>
             <a:ext cx="566928" cy="566928"/>
           </a:xfrm>
           <a:prstGeom prst="ellipse">
@@ -3802,7 +3671,7 @@
       </p:sp>
       <p:pic>
         <p:nvPicPr>
-          <p:cNvPr id="21" name="Image 3" descr="preencoded.png">    </p:cNvPr>
+          <p:cNvPr id="17" name="Image 3" descr="preencoded.png">    </p:cNvPr>
           <p:cNvPicPr>
             <a:picLocks noChangeAspect="1"/>
           </p:cNvPicPr>
@@ -3816,7 +3685,7 @@
         </p:blipFill>
         <p:spPr>
           <a:xfrm>
-            <a:off x="636605" y="3786713"/>
+            <a:off x="8591885" y="2012777"/>
             <a:ext cx="272125" cy="272125"/>
           </a:xfrm>
           <a:prstGeom prst="rect">
@@ -3826,13 +3695,13 @@
       </p:pic>
       <p:sp>
         <p:nvSpPr>
-          <p:cNvPr id="22" name="Text 16"/>
-          <p:cNvSpPr/>
-          <p:nvPr/>
-        </p:nvSpPr>
-        <p:spPr>
-          <a:xfrm>
-            <a:off x="1202436" y="3566160"/>
+          <p:cNvPr id="18" name="Text 12"/>
+          <p:cNvSpPr/>
+          <p:nvPr/>
+        </p:nvSpPr>
+        <p:spPr>
+          <a:xfrm>
+            <a:off x="9157716" y="1792224"/>
             <a:ext cx="2606040" cy="320040"/>
           </a:xfrm>
           <a:prstGeom prst="rect">
@@ -3857,7 +3726,7 @@
                 <a:ea typeface="Calibri" pitchFamily="34" charset="-122"/>
                 <a:cs typeface="Calibri" pitchFamily="34" charset="-120"/>
               </a:rPr>
-              <a:t>4. Model Setup</a:t>
+              <a:t>3. Access Setup</a:t>
             </a:r>
             <a:endParaRPr lang="en-US" sz="1500" dirty="0"/>
           </a:p>
@@ -3865,13 +3734,13 @@
       </p:sp>
       <p:sp>
         <p:nvSpPr>
-          <p:cNvPr id="23" name="Text 17"/>
-          <p:cNvSpPr/>
-          <p:nvPr/>
-        </p:nvSpPr>
-        <p:spPr>
-          <a:xfrm>
-            <a:off x="1202436" y="3895344"/>
+          <p:cNvPr id="19" name="Text 13"/>
+          <p:cNvSpPr/>
+          <p:nvPr/>
+        </p:nvSpPr>
+        <p:spPr>
+          <a:xfrm>
+            <a:off x="9157716" y="2121408"/>
             <a:ext cx="2606040" cy="914400"/>
           </a:xfrm>
           <a:prstGeom prst="rect">
@@ -3896,7 +3765,7 @@
                 <a:ea typeface="Calibri" pitchFamily="34" charset="-122"/>
                 <a:cs typeface="Calibri" pitchFamily="34" charset="-120"/>
               </a:rPr>
-              <a:t>Model-specific track: ungating, memberships, prep center, listing software, product research.</a:t>
+              <a:t>Seller accounts, sourcing accounts, payment (Payoneer / bank), software logins — via secure checklist.</a:t>
             </a:r>
             <a:endParaRPr lang="en-US" sz="1050" dirty="0"/>
           </a:p>
@@ -3904,13 +3773,13 @@
       </p:sp>
       <p:sp>
         <p:nvSpPr>
-          <p:cNvPr id="24" name="Shape 18"/>
-          <p:cNvSpPr/>
-          <p:nvPr/>
-        </p:nvSpPr>
-        <p:spPr>
-          <a:xfrm>
-            <a:off x="4265676" y="3419856"/>
+          <p:cNvPr id="20" name="Shape 14"/>
+          <p:cNvSpPr/>
+          <p:nvPr/>
+        </p:nvSpPr>
+        <p:spPr>
+          <a:xfrm>
+            <a:off x="288036" y="3419856"/>
             <a:ext cx="3657600" cy="1481328"/>
           </a:xfrm>
           <a:prstGeom prst="roundRect">
@@ -3926,13 +3795,13 @@
       </p:sp>
       <p:sp>
         <p:nvSpPr>
-          <p:cNvPr id="25" name="Shape 19"/>
-          <p:cNvSpPr/>
-          <p:nvPr/>
-        </p:nvSpPr>
-        <p:spPr>
-          <a:xfrm>
-            <a:off x="4466844" y="3639312"/>
+          <p:cNvPr id="21" name="Shape 15"/>
+          <p:cNvSpPr/>
+          <p:nvPr/>
+        </p:nvSpPr>
+        <p:spPr>
+          <a:xfrm>
+            <a:off x="489204" y="3639312"/>
             <a:ext cx="566928" cy="566928"/>
           </a:xfrm>
           <a:prstGeom prst="ellipse">
@@ -3946,7 +3815,7 @@
       </p:sp>
       <p:pic>
         <p:nvPicPr>
-          <p:cNvPr id="26" name="Image 4" descr="preencoded.png">    </p:cNvPr>
+          <p:cNvPr id="22" name="Image 4" descr="preencoded.png">    </p:cNvPr>
           <p:cNvPicPr>
             <a:picLocks noChangeAspect="1"/>
           </p:cNvPicPr>
@@ -3960,7 +3829,7 @@
         </p:blipFill>
         <p:spPr>
           <a:xfrm>
-            <a:off x="4614245" y="3786713"/>
+            <a:off x="636605" y="3786713"/>
             <a:ext cx="272125" cy="272125"/>
           </a:xfrm>
           <a:prstGeom prst="rect">
@@ -3970,13 +3839,13 @@
       </p:pic>
       <p:sp>
         <p:nvSpPr>
-          <p:cNvPr id="27" name="Text 20"/>
-          <p:cNvSpPr/>
-          <p:nvPr/>
-        </p:nvSpPr>
-        <p:spPr>
-          <a:xfrm>
-            <a:off x="5180076" y="3566160"/>
+          <p:cNvPr id="23" name="Text 16"/>
+          <p:cNvSpPr/>
+          <p:nvPr/>
+        </p:nvSpPr>
+        <p:spPr>
+          <a:xfrm>
+            <a:off x="1202436" y="3566160"/>
             <a:ext cx="2606040" cy="320040"/>
           </a:xfrm>
           <a:prstGeom prst="rect">
@@ -4001,7 +3870,7 @@
                 <a:ea typeface="Calibri" pitchFamily="34" charset="-122"/>
                 <a:cs typeface="Calibri" pitchFamily="34" charset="-120"/>
               </a:rPr>
-              <a:t>5. Launch</a:t>
+              <a:t>4. Model Setup</a:t>
             </a:r>
             <a:endParaRPr lang="en-US" sz="1500" dirty="0"/>
           </a:p>
@@ -4009,13 +3878,13 @@
       </p:sp>
       <p:sp>
         <p:nvSpPr>
-          <p:cNvPr id="28" name="Text 21"/>
-          <p:cNvSpPr/>
-          <p:nvPr/>
-        </p:nvSpPr>
-        <p:spPr>
-          <a:xfrm>
-            <a:off x="5180076" y="3895344"/>
+          <p:cNvPr id="24" name="Text 17"/>
+          <p:cNvSpPr/>
+          <p:nvPr/>
+        </p:nvSpPr>
+        <p:spPr>
+          <a:xfrm>
+            <a:off x="1202436" y="3895344"/>
             <a:ext cx="2606040" cy="914400"/>
           </a:xfrm>
           <a:prstGeom prst="rect">
@@ -4040,7 +3909,7 @@
                 <a:ea typeface="Calibri" pitchFamily="34" charset="-122"/>
                 <a:cs typeface="Calibri" pitchFamily="34" charset="-120"/>
               </a:rPr>
-              <a:t>First listings live, order flow tested end-to-end with a trial order, buy-box / pricing checks.</a:t>
+              <a:t>Model-specific track: ungating, memberships, prep center, listing software, product research.</a:t>
             </a:r>
             <a:endParaRPr lang="en-US" sz="1050" dirty="0"/>
           </a:p>
@@ -4048,13 +3917,13 @@
       </p:sp>
       <p:sp>
         <p:nvSpPr>
-          <p:cNvPr id="29" name="Shape 22"/>
-          <p:cNvSpPr/>
-          <p:nvPr/>
-        </p:nvSpPr>
-        <p:spPr>
-          <a:xfrm>
-            <a:off x="8243316" y="3419856"/>
+          <p:cNvPr id="25" name="Shape 18"/>
+          <p:cNvSpPr/>
+          <p:nvPr/>
+        </p:nvSpPr>
+        <p:spPr>
+          <a:xfrm>
+            <a:off x="4265676" y="3419856"/>
             <a:ext cx="3657600" cy="1481328"/>
           </a:xfrm>
           <a:prstGeom prst="roundRect">
@@ -4070,13 +3939,13 @@
       </p:sp>
       <p:sp>
         <p:nvSpPr>
-          <p:cNvPr id="30" name="Shape 23"/>
-          <p:cNvSpPr/>
-          <p:nvPr/>
-        </p:nvSpPr>
-        <p:spPr>
-          <a:xfrm>
-            <a:off x="8444484" y="3639312"/>
+          <p:cNvPr id="26" name="Shape 19"/>
+          <p:cNvSpPr/>
+          <p:nvPr/>
+        </p:nvSpPr>
+        <p:spPr>
+          <a:xfrm>
+            <a:off x="4466844" y="3639312"/>
             <a:ext cx="566928" cy="566928"/>
           </a:xfrm>
           <a:prstGeom prst="ellipse">
@@ -4090,7 +3959,7 @@
       </p:sp>
       <p:pic>
         <p:nvPicPr>
-          <p:cNvPr id="31" name="Image 5" descr="preencoded.png">    </p:cNvPr>
+          <p:cNvPr id="27" name="Image 5" descr="preencoded.png">    </p:cNvPr>
           <p:cNvPicPr>
             <a:picLocks noChangeAspect="1"/>
           </p:cNvPicPr>
@@ -4104,6 +3973,150 @@
         </p:blipFill>
         <p:spPr>
           <a:xfrm>
+            <a:off x="4614245" y="3786713"/>
+            <a:ext cx="272125" cy="272125"/>
+          </a:xfrm>
+          <a:prstGeom prst="rect">
+            <a:avLst/>
+          </a:prstGeom>
+        </p:spPr>
+      </p:pic>
+      <p:sp>
+        <p:nvSpPr>
+          <p:cNvPr id="28" name="Text 20"/>
+          <p:cNvSpPr/>
+          <p:nvPr/>
+        </p:nvSpPr>
+        <p:spPr>
+          <a:xfrm>
+            <a:off x="5180076" y="3566160"/>
+            <a:ext cx="2606040" cy="320040"/>
+          </a:xfrm>
+          <a:prstGeom prst="rect">
+            <a:avLst/>
+          </a:prstGeom>
+          <a:noFill/>
+          <a:ln/>
+        </p:spPr>
+        <p:txBody>
+          <a:bodyPr wrap="square" lIns="0" tIns="0" rIns="0" bIns="0" rtlCol="0" anchor="ctr"/>
+          <a:lstStyle/>
+          <a:p>
+            <a:pPr indent="0" marL="0">
+              <a:buNone/>
+            </a:pPr>
+            <a:r>
+              <a:rPr lang="en-US" sz="1500" b="1" dirty="0">
+                <a:solidFill>
+                  <a:srgbClr val="1E2761"/>
+                </a:solidFill>
+                <a:latin typeface="Calibri" pitchFamily="34" charset="0"/>
+                <a:ea typeface="Calibri" pitchFamily="34" charset="-122"/>
+                <a:cs typeface="Calibri" pitchFamily="34" charset="-120"/>
+              </a:rPr>
+              <a:t>5. Launch</a:t>
+            </a:r>
+            <a:endParaRPr lang="en-US" sz="1500" dirty="0"/>
+          </a:p>
+        </p:txBody>
+      </p:sp>
+      <p:sp>
+        <p:nvSpPr>
+          <p:cNvPr id="29" name="Text 21"/>
+          <p:cNvSpPr/>
+          <p:nvPr/>
+        </p:nvSpPr>
+        <p:spPr>
+          <a:xfrm>
+            <a:off x="5180076" y="3895344"/>
+            <a:ext cx="2606040" cy="914400"/>
+          </a:xfrm>
+          <a:prstGeom prst="rect">
+            <a:avLst/>
+          </a:prstGeom>
+          <a:noFill/>
+          <a:ln/>
+        </p:spPr>
+        <p:txBody>
+          <a:bodyPr wrap="square" lIns="0" tIns="0" rIns="0" bIns="0" rtlCol="0" anchor="ctr"/>
+          <a:lstStyle/>
+          <a:p>
+            <a:pPr indent="0" marL="0">
+              <a:buNone/>
+            </a:pPr>
+            <a:r>
+              <a:rPr lang="en-US" sz="1050" dirty="0">
+                <a:solidFill>
+                  <a:srgbClr val="22284A"/>
+                </a:solidFill>
+                <a:latin typeface="Calibri" pitchFamily="34" charset="0"/>
+                <a:ea typeface="Calibri" pitchFamily="34" charset="-122"/>
+                <a:cs typeface="Calibri" pitchFamily="34" charset="-120"/>
+              </a:rPr>
+              <a:t>First listings live, order flow tested end-to-end with a trial order, buy-box / pricing checks.</a:t>
+            </a:r>
+            <a:endParaRPr lang="en-US" sz="1050" dirty="0"/>
+          </a:p>
+        </p:txBody>
+      </p:sp>
+      <p:sp>
+        <p:nvSpPr>
+          <p:cNvPr id="30" name="Shape 22"/>
+          <p:cNvSpPr/>
+          <p:nvPr/>
+        </p:nvSpPr>
+        <p:spPr>
+          <a:xfrm>
+            <a:off x="8243316" y="3419856"/>
+            <a:ext cx="3657600" cy="1481328"/>
+          </a:xfrm>
+          <a:prstGeom prst="roundRect">
+            <a:avLst>
+              <a:gd name="adj" fmla="val 6173"/>
+            </a:avLst>
+          </a:prstGeom>
+          <a:solidFill>
+            <a:srgbClr val="EEF3FF"/>
+          </a:solidFill>
+          <a:ln/>
+        </p:spPr>
+      </p:sp>
+      <p:sp>
+        <p:nvSpPr>
+          <p:cNvPr id="31" name="Shape 23"/>
+          <p:cNvSpPr/>
+          <p:nvPr/>
+        </p:nvSpPr>
+        <p:spPr>
+          <a:xfrm>
+            <a:off x="8444484" y="3639312"/>
+            <a:ext cx="566928" cy="566928"/>
+          </a:xfrm>
+          <a:prstGeom prst="ellipse">
+            <a:avLst/>
+          </a:prstGeom>
+          <a:solidFill>
+            <a:srgbClr val="1E2761"/>
+          </a:solidFill>
+          <a:ln/>
+        </p:spPr>
+      </p:sp>
+      <p:pic>
+        <p:nvPicPr>
+          <p:cNvPr id="32" name="Image 6" descr="preencoded.png">    </p:cNvPr>
+          <p:cNvPicPr>
+            <a:picLocks noChangeAspect="1"/>
+          </p:cNvPicPr>
+          <p:nvPr/>
+        </p:nvPicPr>
+        <p:blipFill>
+          <a:blip r:embed="rId7"/>
+          <a:stretch>
+            <a:fillRect/>
+          </a:stretch>
+        </p:blipFill>
+        <p:spPr>
+          <a:xfrm>
             <a:off x="8591885" y="3786713"/>
             <a:ext cx="272125" cy="272125"/>
           </a:xfrm>
@@ -4114,7 +4127,7 @@
       </p:pic>
       <p:sp>
         <p:nvSpPr>
-          <p:cNvPr id="32" name="Text 24"/>
+          <p:cNvPr id="33" name="Text 24"/>
           <p:cNvSpPr/>
           <p:nvPr/>
         </p:nvSpPr>
@@ -4153,7 +4166,7 @@
       </p:sp>
       <p:sp>
         <p:nvSpPr>
-          <p:cNvPr id="33" name="Text 25"/>
+          <p:cNvPr id="34" name="Text 25"/>
           <p:cNvSpPr/>
           <p:nvPr/>
         </p:nvSpPr>
@@ -4192,7 +4205,7 @@
       </p:sp>
       <p:sp>
         <p:nvSpPr>
-          <p:cNvPr id="34" name="Shape 26"/>
+          <p:cNvPr id="35" name="Shape 26"/>
           <p:cNvSpPr/>
           <p:nvPr/>
         </p:nvSpPr>
@@ -4214,7 +4227,7 @@
       </p:sp>
       <p:sp>
         <p:nvSpPr>
-          <p:cNvPr id="35" name="Text 27"/>
+          <p:cNvPr id="36" name="Text 27"/>
           <p:cNvSpPr/>
           <p:nvPr/>
         </p:nvSpPr>
@@ -7837,129 +7850,9 @@
           <a:chExt cx="0" cy="0"/>
         </a:xfrm>
       </p:grpSpPr>
-      <p:sp>
-        <p:nvSpPr>
-          <p:cNvPr id="2" name="Text 0"/>
-          <p:cNvSpPr/>
-          <p:nvPr/>
-        </p:nvSpPr>
-        <p:spPr>
-          <a:xfrm>
-            <a:off x="548640" y="320040"/>
-            <a:ext cx="11064240" cy="685800"/>
-          </a:xfrm>
-          <a:prstGeom prst="rect">
-            <a:avLst/>
-          </a:prstGeom>
-          <a:noFill/>
-          <a:ln/>
-        </p:spPr>
-        <p:txBody>
-          <a:bodyPr wrap="square" lIns="0" tIns="0" rIns="0" bIns="0" rtlCol="0" anchor="ctr"/>
-          <a:lstStyle/>
-          <a:p>
-            <a:pPr indent="0" marL="0">
-              <a:buNone/>
-            </a:pPr>
-            <a:r>
-              <a:rPr lang="en-US" sz="3200" b="1" dirty="0">
-                <a:solidFill>
-                  <a:srgbClr val="1E2761"/>
-                </a:solidFill>
-                <a:latin typeface="Cambria" pitchFamily="34" charset="0"/>
-                <a:ea typeface="Cambria" pitchFamily="34" charset="-122"/>
-                <a:cs typeface="Cambria" pitchFamily="34" charset="-120"/>
-              </a:rPr>
-              <a:t>Client Requirements at a Glance</a:t>
-            </a:r>
-            <a:endParaRPr lang="en-US" sz="3200" dirty="0"/>
-          </a:p>
-        </p:txBody>
-      </p:sp>
-      <p:sp>
-        <p:nvSpPr>
-          <p:cNvPr id="3" name="Text 1"/>
-          <p:cNvSpPr/>
-          <p:nvPr/>
-        </p:nvSpPr>
-        <p:spPr>
-          <a:xfrm>
-            <a:off x="548640" y="960120"/>
-            <a:ext cx="11064240" cy="365760"/>
-          </a:xfrm>
-          <a:prstGeom prst="rect">
-            <a:avLst/>
-          </a:prstGeom>
-          <a:noFill/>
-          <a:ln/>
-        </p:spPr>
-        <p:txBody>
-          <a:bodyPr wrap="square" lIns="0" tIns="0" rIns="0" bIns="0" rtlCol="0" anchor="ctr"/>
-          <a:lstStyle/>
-          <a:p>
-            <a:pPr indent="0" marL="0">
-              <a:buNone/>
-            </a:pPr>
-            <a:r>
-              <a:rPr lang="en-US" sz="1400" i="1" dirty="0">
-                <a:solidFill>
-                  <a:srgbClr val="5A6285"/>
-                </a:solidFill>
-                <a:latin typeface="Calibri" pitchFamily="34" charset="0"/>
-                <a:ea typeface="Calibri" pitchFamily="34" charset="-122"/>
-                <a:cs typeface="Calibri" pitchFamily="34" charset="-120"/>
-              </a:rPr>
-              <a:t>The checklist we walk through on the kickoff call — one page per client, signed off before we build</a:t>
-            </a:r>
-            <a:endParaRPr lang="en-US" sz="1400" dirty="0"/>
-          </a:p>
-        </p:txBody>
-      </p:sp>
-      <p:sp>
-        <p:nvSpPr>
-          <p:cNvPr id="4" name="Shape 2"/>
-          <p:cNvSpPr/>
-          <p:nvPr/>
-        </p:nvSpPr>
-        <p:spPr>
-          <a:xfrm>
-            <a:off x="493776" y="1600200"/>
-            <a:ext cx="3520440" cy="3794760"/>
-          </a:xfrm>
-          <a:prstGeom prst="roundRect">
-            <a:avLst>
-              <a:gd name="adj" fmla="val 3117"/>
-            </a:avLst>
-          </a:prstGeom>
-          <a:solidFill>
-            <a:srgbClr val="F4F7FE"/>
-          </a:solidFill>
-          <a:ln/>
-        </p:spPr>
-      </p:sp>
-      <p:sp>
-        <p:nvSpPr>
-          <p:cNvPr id="5" name="Shape 3"/>
-          <p:cNvSpPr/>
-          <p:nvPr/>
-        </p:nvSpPr>
-        <p:spPr>
-          <a:xfrm>
-            <a:off x="768096" y="1847088"/>
-            <a:ext cx="594360" cy="594360"/>
-          </a:xfrm>
-          <a:prstGeom prst="ellipse">
-            <a:avLst/>
-          </a:prstGeom>
-          <a:solidFill>
-            <a:srgbClr val="CADCFC"/>
-          </a:solidFill>
-          <a:ln/>
-        </p:spPr>
-      </p:sp>
       <p:pic>
         <p:nvPicPr>
-          <p:cNvPr id="6" name="Image 0" descr="preencoded.png">    </p:cNvPr>
+          <p:cNvPr id="2" name="Image 0" descr="preencoded.png">    </p:cNvPr>
           <p:cNvPicPr>
             <a:picLocks noChangeAspect="1"/>
           </p:cNvPicPr>
@@ -7973,8 +7866,8 @@
         </p:blipFill>
         <p:spPr>
           <a:xfrm>
-            <a:off x="900684" y="1979676"/>
-            <a:ext cx="329184" cy="329184"/>
+            <a:off x="9720072" y="384048"/>
+            <a:ext cx="1920240" cy="521208"/>
           </a:xfrm>
           <a:prstGeom prst="rect">
             <a:avLst/>
@@ -7983,14 +7876,14 @@
       </p:pic>
       <p:sp>
         <p:nvSpPr>
-          <p:cNvPr id="7" name="Text 4"/>
-          <p:cNvSpPr/>
-          <p:nvPr/>
-        </p:nvSpPr>
-        <p:spPr>
-          <a:xfrm>
-            <a:off x="1499616" y="1847088"/>
-            <a:ext cx="2331720" cy="594360"/>
+          <p:cNvPr id="3" name="Text 0"/>
+          <p:cNvSpPr/>
+          <p:nvPr/>
+        </p:nvSpPr>
+        <p:spPr>
+          <a:xfrm>
+            <a:off x="548640" y="320040"/>
+            <a:ext cx="9052560" cy="685800"/>
           </a:xfrm>
           <a:prstGeom prst="rect">
             <a:avLst/>
@@ -8006,156 +7899,68 @@
               <a:buNone/>
             </a:pPr>
             <a:r>
-              <a:rPr lang="en-US" sz="1650" b="1" dirty="0">
+              <a:rPr lang="en-US" sz="3200" b="1" dirty="0">
                 <a:solidFill>
                   <a:srgbClr val="1E2761"/>
                 </a:solidFill>
-                <a:latin typeface="Calibri" pitchFamily="34" charset="0"/>
-                <a:ea typeface="Calibri" pitchFamily="34" charset="-122"/>
-                <a:cs typeface="Calibri" pitchFamily="34" charset="-120"/>
-              </a:rPr>
-              <a:t>Amazon 2-Step</a:t>
-            </a:r>
-            <a:endParaRPr lang="en-US" sz="1650" dirty="0"/>
-          </a:p>
-        </p:txBody>
-      </p:sp>
-      <p:sp>
-        <p:nvSpPr>
-          <p:cNvPr id="8" name="Text 5"/>
-          <p:cNvSpPr/>
-          <p:nvPr/>
-        </p:nvSpPr>
-        <p:spPr>
-          <a:xfrm>
-            <a:off x="813816" y="2697480"/>
-            <a:ext cx="2926080" cy="2560320"/>
-          </a:xfrm>
-          <a:prstGeom prst="rect">
-            <a:avLst/>
-          </a:prstGeom>
-          <a:noFill/>
-          <a:ln/>
-        </p:spPr>
-        <p:txBody>
-          <a:bodyPr wrap="square" lIns="0" tIns="0" rIns="0" bIns="0" rtlCol="0" anchor="ctr"/>
-          <a:lstStyle/>
-          <a:p>
-            <a:pPr marL="342900" indent="-342900">
-              <a:spcAft>
-                <a:spcPts val="1000"/>
-              </a:spcAft>
-              <a:buSzPct val="100000"/>
-              <a:buChar char="•"/>
-            </a:pPr>
-            <a:r>
-              <a:rPr lang="en-US" sz="1250" dirty="0">
-                <a:solidFill>
-                  <a:srgbClr val="22284A"/>
-                </a:solidFill>
-                <a:latin typeface="Calibri" pitchFamily="34" charset="0"/>
-                <a:ea typeface="Calibri" pitchFamily="34" charset="-122"/>
-                <a:cs typeface="Calibri" pitchFamily="34" charset="-120"/>
-              </a:rPr>
-              <a:t>Amazon Seller account</a:t>
-            </a:r>
-            <a:endParaRPr lang="en-US" sz="1250" dirty="0"/>
-          </a:p>
-          <a:p>
-            <a:pPr marL="342900" indent="-342900">
-              <a:spcAft>
-                <a:spcPts val="1000"/>
-              </a:spcAft>
-              <a:buSzPct val="100000"/>
-              <a:buChar char="•"/>
-            </a:pPr>
-            <a:r>
-              <a:rPr lang="en-US" sz="1250" dirty="0">
-                <a:solidFill>
-                  <a:srgbClr val="22284A"/>
-                </a:solidFill>
-                <a:latin typeface="Calibri" pitchFamily="34" charset="0"/>
-                <a:ea typeface="Calibri" pitchFamily="34" charset="-122"/>
-                <a:cs typeface="Calibri" pitchFamily="34" charset="-120"/>
-              </a:rPr>
-              <a:t>LLC + EIN (recommended)</a:t>
-            </a:r>
-            <a:endParaRPr lang="en-US" sz="1250" dirty="0"/>
-          </a:p>
-          <a:p>
-            <a:pPr marL="342900" indent="-342900">
-              <a:spcAft>
-                <a:spcPts val="1000"/>
-              </a:spcAft>
-              <a:buSzPct val="100000"/>
-              <a:buChar char="•"/>
-            </a:pPr>
-            <a:r>
-              <a:rPr lang="en-US" sz="1250" dirty="0">
-                <a:solidFill>
-                  <a:srgbClr val="22284A"/>
-                </a:solidFill>
-                <a:latin typeface="Calibri" pitchFamily="34" charset="0"/>
-                <a:ea typeface="Calibri" pitchFamily="34" charset="-122"/>
-                <a:cs typeface="Calibri" pitchFamily="34" charset="-120"/>
-              </a:rPr>
-              <a:t>Sam's Club + Walmart memberships</a:t>
-            </a:r>
-            <a:endParaRPr lang="en-US" sz="1250" dirty="0"/>
-          </a:p>
-          <a:p>
-            <a:pPr marL="342900" indent="-342900">
-              <a:spcAft>
-                <a:spcPts val="1000"/>
-              </a:spcAft>
-              <a:buSzPct val="100000"/>
-              <a:buChar char="•"/>
-            </a:pPr>
-            <a:r>
-              <a:rPr lang="en-US" sz="1250" dirty="0">
-                <a:solidFill>
-                  <a:srgbClr val="22284A"/>
-                </a:solidFill>
-                <a:latin typeface="Calibri" pitchFamily="34" charset="0"/>
-                <a:ea typeface="Calibri" pitchFamily="34" charset="-122"/>
-                <a:cs typeface="Calibri" pitchFamily="34" charset="-120"/>
-              </a:rPr>
-              <a:t>Payoneer / US bank</a:t>
-            </a:r>
-            <a:endParaRPr lang="en-US" sz="1250" dirty="0"/>
-          </a:p>
-          <a:p>
-            <a:pPr marL="342900" indent="-342900">
-              <a:spcAft>
-                <a:spcPts val="1000"/>
-              </a:spcAft>
-              <a:buSzPct val="100000"/>
-              <a:buChar char="•"/>
-            </a:pPr>
-            <a:r>
-              <a:rPr lang="en-US" sz="1250" dirty="0">
-                <a:solidFill>
-                  <a:srgbClr val="22284A"/>
-                </a:solidFill>
-                <a:latin typeface="Calibri" pitchFamily="34" charset="0"/>
-                <a:ea typeface="Calibri" pitchFamily="34" charset="-122"/>
-                <a:cs typeface="Calibri" pitchFamily="34" charset="-120"/>
-              </a:rPr>
-              <a:t>$1.5k–$3k starting float</a:t>
-            </a:r>
-            <a:endParaRPr lang="en-US" sz="1250" dirty="0"/>
-          </a:p>
-        </p:txBody>
-      </p:sp>
-      <p:sp>
-        <p:nvSpPr>
-          <p:cNvPr id="9" name="Shape 6"/>
-          <p:cNvSpPr/>
-          <p:nvPr/>
-        </p:nvSpPr>
-        <p:spPr>
-          <a:xfrm>
-            <a:off x="4334256" y="1600200"/>
+                <a:latin typeface="Cambria" pitchFamily="34" charset="0"/>
+                <a:ea typeface="Cambria" pitchFamily="34" charset="-122"/>
+                <a:cs typeface="Cambria" pitchFamily="34" charset="-120"/>
+              </a:rPr>
+              <a:t>Client Requirements at a Glance</a:t>
+            </a:r>
+            <a:endParaRPr lang="en-US" sz="3200" dirty="0"/>
+          </a:p>
+        </p:txBody>
+      </p:sp>
+      <p:sp>
+        <p:nvSpPr>
+          <p:cNvPr id="4" name="Text 1"/>
+          <p:cNvSpPr/>
+          <p:nvPr/>
+        </p:nvSpPr>
+        <p:spPr>
+          <a:xfrm>
+            <a:off x="548640" y="960120"/>
+            <a:ext cx="11064240" cy="365760"/>
+          </a:xfrm>
+          <a:prstGeom prst="rect">
+            <a:avLst/>
+          </a:prstGeom>
+          <a:noFill/>
+          <a:ln/>
+        </p:spPr>
+        <p:txBody>
+          <a:bodyPr wrap="square" lIns="0" tIns="0" rIns="0" bIns="0" rtlCol="0" anchor="ctr"/>
+          <a:lstStyle/>
+          <a:p>
+            <a:pPr indent="0" marL="0">
+              <a:buNone/>
+            </a:pPr>
+            <a:r>
+              <a:rPr lang="en-US" sz="1400" i="1" dirty="0">
+                <a:solidFill>
+                  <a:srgbClr val="5A6285"/>
+                </a:solidFill>
+                <a:latin typeface="Calibri" pitchFamily="34" charset="0"/>
+                <a:ea typeface="Calibri" pitchFamily="34" charset="-122"/>
+                <a:cs typeface="Calibri" pitchFamily="34" charset="-120"/>
+              </a:rPr>
+              <a:t>The checklist we walk through on the kickoff call — one page per client, signed off before we build</a:t>
+            </a:r>
+            <a:endParaRPr lang="en-US" sz="1400" dirty="0"/>
+          </a:p>
+        </p:txBody>
+      </p:sp>
+      <p:sp>
+        <p:nvSpPr>
+          <p:cNvPr id="5" name="Shape 2"/>
+          <p:cNvSpPr/>
+          <p:nvPr/>
+        </p:nvSpPr>
+        <p:spPr>
+          <a:xfrm>
+            <a:off x="493776" y="1600200"/>
             <a:ext cx="3520440" cy="3794760"/>
           </a:xfrm>
           <a:prstGeom prst="roundRect">
@@ -8171,13 +7976,13 @@
       </p:sp>
       <p:sp>
         <p:nvSpPr>
-          <p:cNvPr id="10" name="Shape 7"/>
-          <p:cNvSpPr/>
-          <p:nvPr/>
-        </p:nvSpPr>
-        <p:spPr>
-          <a:xfrm>
-            <a:off x="4608576" y="1847088"/>
+          <p:cNvPr id="6" name="Shape 3"/>
+          <p:cNvSpPr/>
+          <p:nvPr/>
+        </p:nvSpPr>
+        <p:spPr>
+          <a:xfrm>
+            <a:off x="768096" y="1847088"/>
             <a:ext cx="594360" cy="594360"/>
           </a:xfrm>
           <a:prstGeom prst="ellipse">
@@ -8191,7 +7996,7 @@
       </p:sp>
       <p:pic>
         <p:nvPicPr>
-          <p:cNvPr id="11" name="Image 1" descr="preencoded.png">    </p:cNvPr>
+          <p:cNvPr id="7" name="Image 1" descr="preencoded.png">    </p:cNvPr>
           <p:cNvPicPr>
             <a:picLocks noChangeAspect="1"/>
           </p:cNvPicPr>
@@ -8205,7 +8010,7 @@
         </p:blipFill>
         <p:spPr>
           <a:xfrm>
-            <a:off x="4741164" y="1979676"/>
+            <a:off x="900684" y="1979676"/>
             <a:ext cx="329184" cy="329184"/>
           </a:xfrm>
           <a:prstGeom prst="rect">
@@ -8215,13 +8020,13 @@
       </p:pic>
       <p:sp>
         <p:nvSpPr>
-          <p:cNvPr id="12" name="Text 8"/>
-          <p:cNvSpPr/>
-          <p:nvPr/>
-        </p:nvSpPr>
-        <p:spPr>
-          <a:xfrm>
-            <a:off x="5340096" y="1847088"/>
+          <p:cNvPr id="8" name="Text 4"/>
+          <p:cNvSpPr/>
+          <p:nvPr/>
+        </p:nvSpPr>
+        <p:spPr>
+          <a:xfrm>
+            <a:off x="1499616" y="1847088"/>
             <a:ext cx="2331720" cy="594360"/>
           </a:xfrm>
           <a:prstGeom prst="rect">
@@ -8246,7 +8051,7 @@
                 <a:ea typeface="Calibri" pitchFamily="34" charset="-122"/>
                 <a:cs typeface="Calibri" pitchFamily="34" charset="-120"/>
               </a:rPr>
-              <a:t>eBay Dropshipping</a:t>
+              <a:t>Amazon 2-Step</a:t>
             </a:r>
             <a:endParaRPr lang="en-US" sz="1650" dirty="0"/>
           </a:p>
@@ -8254,13 +8059,13 @@
       </p:sp>
       <p:sp>
         <p:nvSpPr>
-          <p:cNvPr id="13" name="Text 9"/>
-          <p:cNvSpPr/>
-          <p:nvPr/>
-        </p:nvSpPr>
-        <p:spPr>
-          <a:xfrm>
-            <a:off x="4654296" y="2697480"/>
+          <p:cNvPr id="9" name="Text 5"/>
+          <p:cNvSpPr/>
+          <p:nvPr/>
+        </p:nvSpPr>
+        <p:spPr>
+          <a:xfrm>
+            <a:off x="813816" y="2697480"/>
             <a:ext cx="2926080" cy="2560320"/>
           </a:xfrm>
           <a:prstGeom prst="rect">
@@ -8289,7 +8094,7 @@
                 <a:ea typeface="Calibri" pitchFamily="34" charset="-122"/>
                 <a:cs typeface="Calibri" pitchFamily="34" charset="-120"/>
               </a:rPr>
-              <a:t>eBay Seller account</a:t>
+              <a:t>Amazon Seller account</a:t>
             </a:r>
             <a:endParaRPr lang="en-US" sz="1250" dirty="0"/>
           </a:p>
@@ -8310,7 +8115,7 @@
                 <a:ea typeface="Calibri" pitchFamily="34" charset="-122"/>
                 <a:cs typeface="Calibri" pitchFamily="34" charset="-120"/>
               </a:rPr>
-              <a:t>PayPal / Payoneer</a:t>
+              <a:t>LLC + EIN (recommended)</a:t>
             </a:r>
             <a:endParaRPr lang="en-US" sz="1250" dirty="0"/>
           </a:p>
@@ -8331,7 +8136,7 @@
                 <a:ea typeface="Calibri" pitchFamily="34" charset="-122"/>
                 <a:cs typeface="Calibri" pitchFamily="34" charset="-120"/>
               </a:rPr>
-              <a:t>AliExpress + Temu + Walmart accounts</a:t>
+              <a:t>Sam's Club + Walmart memberships</a:t>
             </a:r>
             <a:endParaRPr lang="en-US" sz="1250" dirty="0"/>
           </a:p>
@@ -8352,7 +8157,7 @@
                 <a:ea typeface="Calibri" pitchFamily="34" charset="-122"/>
                 <a:cs typeface="Calibri" pitchFamily="34" charset="-120"/>
               </a:rPr>
-              <a:t>No LLC required to start</a:t>
+              <a:t>Payoneer / US bank</a:t>
             </a:r>
             <a:endParaRPr lang="en-US" sz="1250" dirty="0"/>
           </a:p>
@@ -8373,7 +8178,7 @@
                 <a:ea typeface="Calibri" pitchFamily="34" charset="-122"/>
                 <a:cs typeface="Calibri" pitchFamily="34" charset="-120"/>
               </a:rPr>
-              <a:t>$500–$1k starting float</a:t>
+              <a:t>$1.5k–$3k starting float</a:t>
             </a:r>
             <a:endParaRPr lang="en-US" sz="1250" dirty="0"/>
           </a:p>
@@ -8381,13 +8186,13 @@
       </p:sp>
       <p:sp>
         <p:nvSpPr>
-          <p:cNvPr id="14" name="Shape 10"/>
-          <p:cNvSpPr/>
-          <p:nvPr/>
-        </p:nvSpPr>
-        <p:spPr>
-          <a:xfrm>
-            <a:off x="8174736" y="1600200"/>
+          <p:cNvPr id="10" name="Shape 6"/>
+          <p:cNvSpPr/>
+          <p:nvPr/>
+        </p:nvSpPr>
+        <p:spPr>
+          <a:xfrm>
+            <a:off x="4334256" y="1600200"/>
             <a:ext cx="3520440" cy="3794760"/>
           </a:xfrm>
           <a:prstGeom prst="roundRect">
@@ -8403,13 +8208,13 @@
       </p:sp>
       <p:sp>
         <p:nvSpPr>
-          <p:cNvPr id="15" name="Shape 11"/>
-          <p:cNvSpPr/>
-          <p:nvPr/>
-        </p:nvSpPr>
-        <p:spPr>
-          <a:xfrm>
-            <a:off x="8449056" y="1847088"/>
+          <p:cNvPr id="11" name="Shape 7"/>
+          <p:cNvSpPr/>
+          <p:nvPr/>
+        </p:nvSpPr>
+        <p:spPr>
+          <a:xfrm>
+            <a:off x="4608576" y="1847088"/>
             <a:ext cx="594360" cy="594360"/>
           </a:xfrm>
           <a:prstGeom prst="ellipse">
@@ -8423,7 +8228,7 @@
       </p:sp>
       <p:pic>
         <p:nvPicPr>
-          <p:cNvPr id="16" name="Image 2" descr="preencoded.png">    </p:cNvPr>
+          <p:cNvPr id="12" name="Image 2" descr="preencoded.png">    </p:cNvPr>
           <p:cNvPicPr>
             <a:picLocks noChangeAspect="1"/>
           </p:cNvPicPr>
@@ -8437,7 +8242,7 @@
         </p:blipFill>
         <p:spPr>
           <a:xfrm>
-            <a:off x="8581644" y="1979676"/>
+            <a:off x="4741164" y="1979676"/>
             <a:ext cx="329184" cy="329184"/>
           </a:xfrm>
           <a:prstGeom prst="rect">
@@ -8447,13 +8252,13 @@
       </p:pic>
       <p:sp>
         <p:nvSpPr>
-          <p:cNvPr id="17" name="Text 12"/>
-          <p:cNvSpPr/>
-          <p:nvPr/>
-        </p:nvSpPr>
-        <p:spPr>
-          <a:xfrm>
-            <a:off x="9180576" y="1847088"/>
+          <p:cNvPr id="13" name="Text 8"/>
+          <p:cNvSpPr/>
+          <p:nvPr/>
+        </p:nvSpPr>
+        <p:spPr>
+          <a:xfrm>
+            <a:off x="5340096" y="1847088"/>
             <a:ext cx="2331720" cy="594360"/>
           </a:xfrm>
           <a:prstGeom prst="rect">
@@ -8478,7 +8283,7 @@
                 <a:ea typeface="Calibri" pitchFamily="34" charset="-122"/>
                 <a:cs typeface="Calibri" pitchFamily="34" charset="-120"/>
               </a:rPr>
-              <a:t>Walmart 2-Step</a:t>
+              <a:t>eBay Dropshipping</a:t>
             </a:r>
             <a:endParaRPr lang="en-US" sz="1650" dirty="0"/>
           </a:p>
@@ -8486,13 +8291,13 @@
       </p:sp>
       <p:sp>
         <p:nvSpPr>
-          <p:cNvPr id="18" name="Text 13"/>
-          <p:cNvSpPr/>
-          <p:nvPr/>
-        </p:nvSpPr>
-        <p:spPr>
-          <a:xfrm>
-            <a:off x="8494776" y="2697480"/>
+          <p:cNvPr id="14" name="Text 9"/>
+          <p:cNvSpPr/>
+          <p:nvPr/>
+        </p:nvSpPr>
+        <p:spPr>
+          <a:xfrm>
+            <a:off x="4654296" y="2697480"/>
             <a:ext cx="2926080" cy="2560320"/>
           </a:xfrm>
           <a:prstGeom prst="rect">
@@ -8521,7 +8326,7 @@
                 <a:ea typeface="Calibri" pitchFamily="34" charset="-122"/>
                 <a:cs typeface="Calibri" pitchFamily="34" charset="-120"/>
               </a:rPr>
-              <a:t>US LLC + EIN + W-9 (mandatory)</a:t>
+              <a:t>eBay Seller account</a:t>
             </a:r>
             <a:endParaRPr lang="en-US" sz="1250" dirty="0"/>
           </a:p>
@@ -8542,7 +8347,7 @@
                 <a:ea typeface="Calibri" pitchFamily="34" charset="-122"/>
                 <a:cs typeface="Calibri" pitchFamily="34" charset="-120"/>
               </a:rPr>
-              <a:t>Walmart Seller approval</a:t>
+              <a:t>PayPal / Payoneer</a:t>
             </a:r>
             <a:endParaRPr lang="en-US" sz="1250" dirty="0"/>
           </a:p>
@@ -8563,7 +8368,7 @@
                 <a:ea typeface="Calibri" pitchFamily="34" charset="-122"/>
                 <a:cs typeface="Calibri" pitchFamily="34" charset="-120"/>
               </a:rPr>
-              <a:t>Sam's Club membership</a:t>
+              <a:t>AliExpress + Temu + Walmart accounts</a:t>
             </a:r>
             <a:endParaRPr lang="en-US" sz="1250" dirty="0"/>
           </a:p>
@@ -8584,7 +8389,7 @@
                 <a:ea typeface="Calibri" pitchFamily="34" charset="-122"/>
                 <a:cs typeface="Calibri" pitchFamily="34" charset="-120"/>
               </a:rPr>
-              <a:t>Payoneer / US bank</a:t>
+              <a:t>No LLC required to start</a:t>
             </a:r>
             <a:endParaRPr lang="en-US" sz="1250" dirty="0"/>
           </a:p>
@@ -8605,6 +8410,238 @@
                 <a:ea typeface="Calibri" pitchFamily="34" charset="-122"/>
                 <a:cs typeface="Calibri" pitchFamily="34" charset="-120"/>
               </a:rPr>
+              <a:t>$500–$1k starting float</a:t>
+            </a:r>
+            <a:endParaRPr lang="en-US" sz="1250" dirty="0"/>
+          </a:p>
+        </p:txBody>
+      </p:sp>
+      <p:sp>
+        <p:nvSpPr>
+          <p:cNvPr id="15" name="Shape 10"/>
+          <p:cNvSpPr/>
+          <p:nvPr/>
+        </p:nvSpPr>
+        <p:spPr>
+          <a:xfrm>
+            <a:off x="8174736" y="1600200"/>
+            <a:ext cx="3520440" cy="3794760"/>
+          </a:xfrm>
+          <a:prstGeom prst="roundRect">
+            <a:avLst>
+              <a:gd name="adj" fmla="val 3117"/>
+            </a:avLst>
+          </a:prstGeom>
+          <a:solidFill>
+            <a:srgbClr val="F4F7FE"/>
+          </a:solidFill>
+          <a:ln/>
+        </p:spPr>
+      </p:sp>
+      <p:sp>
+        <p:nvSpPr>
+          <p:cNvPr id="16" name="Shape 11"/>
+          <p:cNvSpPr/>
+          <p:nvPr/>
+        </p:nvSpPr>
+        <p:spPr>
+          <a:xfrm>
+            <a:off x="8449056" y="1847088"/>
+            <a:ext cx="594360" cy="594360"/>
+          </a:xfrm>
+          <a:prstGeom prst="ellipse">
+            <a:avLst/>
+          </a:prstGeom>
+          <a:solidFill>
+            <a:srgbClr val="CADCFC"/>
+          </a:solidFill>
+          <a:ln/>
+        </p:spPr>
+      </p:sp>
+      <p:pic>
+        <p:nvPicPr>
+          <p:cNvPr id="17" name="Image 3" descr="preencoded.png">    </p:cNvPr>
+          <p:cNvPicPr>
+            <a:picLocks noChangeAspect="1"/>
+          </p:cNvPicPr>
+          <p:nvPr/>
+        </p:nvPicPr>
+        <p:blipFill>
+          <a:blip r:embed="rId4"/>
+          <a:stretch>
+            <a:fillRect/>
+          </a:stretch>
+        </p:blipFill>
+        <p:spPr>
+          <a:xfrm>
+            <a:off x="8581644" y="1979676"/>
+            <a:ext cx="329184" cy="329184"/>
+          </a:xfrm>
+          <a:prstGeom prst="rect">
+            <a:avLst/>
+          </a:prstGeom>
+        </p:spPr>
+      </p:pic>
+      <p:sp>
+        <p:nvSpPr>
+          <p:cNvPr id="18" name="Text 12"/>
+          <p:cNvSpPr/>
+          <p:nvPr/>
+        </p:nvSpPr>
+        <p:spPr>
+          <a:xfrm>
+            <a:off x="9180576" y="1847088"/>
+            <a:ext cx="2331720" cy="594360"/>
+          </a:xfrm>
+          <a:prstGeom prst="rect">
+            <a:avLst/>
+          </a:prstGeom>
+          <a:noFill/>
+          <a:ln/>
+        </p:spPr>
+        <p:txBody>
+          <a:bodyPr wrap="square" lIns="0" tIns="0" rIns="0" bIns="0" rtlCol="0" anchor="ctr"/>
+          <a:lstStyle/>
+          <a:p>
+            <a:pPr indent="0" marL="0">
+              <a:buNone/>
+            </a:pPr>
+            <a:r>
+              <a:rPr lang="en-US" sz="1650" b="1" dirty="0">
+                <a:solidFill>
+                  <a:srgbClr val="1E2761"/>
+                </a:solidFill>
+                <a:latin typeface="Calibri" pitchFamily="34" charset="0"/>
+                <a:ea typeface="Calibri" pitchFamily="34" charset="-122"/>
+                <a:cs typeface="Calibri" pitchFamily="34" charset="-120"/>
+              </a:rPr>
+              <a:t>Walmart 2-Step</a:t>
+            </a:r>
+            <a:endParaRPr lang="en-US" sz="1650" dirty="0"/>
+          </a:p>
+        </p:txBody>
+      </p:sp>
+      <p:sp>
+        <p:nvSpPr>
+          <p:cNvPr id="19" name="Text 13"/>
+          <p:cNvSpPr/>
+          <p:nvPr/>
+        </p:nvSpPr>
+        <p:spPr>
+          <a:xfrm>
+            <a:off x="8494776" y="2697480"/>
+            <a:ext cx="2926080" cy="2560320"/>
+          </a:xfrm>
+          <a:prstGeom prst="rect">
+            <a:avLst/>
+          </a:prstGeom>
+          <a:noFill/>
+          <a:ln/>
+        </p:spPr>
+        <p:txBody>
+          <a:bodyPr wrap="square" lIns="0" tIns="0" rIns="0" bIns="0" rtlCol="0" anchor="ctr"/>
+          <a:lstStyle/>
+          <a:p>
+            <a:pPr marL="342900" indent="-342900">
+              <a:spcAft>
+                <a:spcPts val="1000"/>
+              </a:spcAft>
+              <a:buSzPct val="100000"/>
+              <a:buChar char="•"/>
+            </a:pPr>
+            <a:r>
+              <a:rPr lang="en-US" sz="1250" dirty="0">
+                <a:solidFill>
+                  <a:srgbClr val="22284A"/>
+                </a:solidFill>
+                <a:latin typeface="Calibri" pitchFamily="34" charset="0"/>
+                <a:ea typeface="Calibri" pitchFamily="34" charset="-122"/>
+                <a:cs typeface="Calibri" pitchFamily="34" charset="-120"/>
+              </a:rPr>
+              <a:t>US LLC + EIN + W-9 (mandatory)</a:t>
+            </a:r>
+            <a:endParaRPr lang="en-US" sz="1250" dirty="0"/>
+          </a:p>
+          <a:p>
+            <a:pPr marL="342900" indent="-342900">
+              <a:spcAft>
+                <a:spcPts val="1000"/>
+              </a:spcAft>
+              <a:buSzPct val="100000"/>
+              <a:buChar char="•"/>
+            </a:pPr>
+            <a:r>
+              <a:rPr lang="en-US" sz="1250" dirty="0">
+                <a:solidFill>
+                  <a:srgbClr val="22284A"/>
+                </a:solidFill>
+                <a:latin typeface="Calibri" pitchFamily="34" charset="0"/>
+                <a:ea typeface="Calibri" pitchFamily="34" charset="-122"/>
+                <a:cs typeface="Calibri" pitchFamily="34" charset="-120"/>
+              </a:rPr>
+              <a:t>Walmart Seller approval</a:t>
+            </a:r>
+            <a:endParaRPr lang="en-US" sz="1250" dirty="0"/>
+          </a:p>
+          <a:p>
+            <a:pPr marL="342900" indent="-342900">
+              <a:spcAft>
+                <a:spcPts val="1000"/>
+              </a:spcAft>
+              <a:buSzPct val="100000"/>
+              <a:buChar char="•"/>
+            </a:pPr>
+            <a:r>
+              <a:rPr lang="en-US" sz="1250" dirty="0">
+                <a:solidFill>
+                  <a:srgbClr val="22284A"/>
+                </a:solidFill>
+                <a:latin typeface="Calibri" pitchFamily="34" charset="0"/>
+                <a:ea typeface="Calibri" pitchFamily="34" charset="-122"/>
+                <a:cs typeface="Calibri" pitchFamily="34" charset="-120"/>
+              </a:rPr>
+              <a:t>Sam's Club membership</a:t>
+            </a:r>
+            <a:endParaRPr lang="en-US" sz="1250" dirty="0"/>
+          </a:p>
+          <a:p>
+            <a:pPr marL="342900" indent="-342900">
+              <a:spcAft>
+                <a:spcPts val="1000"/>
+              </a:spcAft>
+              <a:buSzPct val="100000"/>
+              <a:buChar char="•"/>
+            </a:pPr>
+            <a:r>
+              <a:rPr lang="en-US" sz="1250" dirty="0">
+                <a:solidFill>
+                  <a:srgbClr val="22284A"/>
+                </a:solidFill>
+                <a:latin typeface="Calibri" pitchFamily="34" charset="0"/>
+                <a:ea typeface="Calibri" pitchFamily="34" charset="-122"/>
+                <a:cs typeface="Calibri" pitchFamily="34" charset="-120"/>
+              </a:rPr>
+              <a:t>Payoneer / US bank</a:t>
+            </a:r>
+            <a:endParaRPr lang="en-US" sz="1250" dirty="0"/>
+          </a:p>
+          <a:p>
+            <a:pPr marL="342900" indent="-342900">
+              <a:spcAft>
+                <a:spcPts val="1000"/>
+              </a:spcAft>
+              <a:buSzPct val="100000"/>
+              <a:buChar char="•"/>
+            </a:pPr>
+            <a:r>
+              <a:rPr lang="en-US" sz="1250" dirty="0">
+                <a:solidFill>
+                  <a:srgbClr val="22284A"/>
+                </a:solidFill>
+                <a:latin typeface="Calibri" pitchFamily="34" charset="0"/>
+                <a:ea typeface="Calibri" pitchFamily="34" charset="-122"/>
+                <a:cs typeface="Calibri" pitchFamily="34" charset="-120"/>
+              </a:rPr>
               <a:t>$1.5k–$3k starting float</a:t>
             </a:r>
             <a:endParaRPr lang="en-US" sz="1250" dirty="0"/>
@@ -8613,7 +8650,7 @@
       </p:sp>
       <p:sp>
         <p:nvSpPr>
-          <p:cNvPr id="19" name="Shape 14"/>
+          <p:cNvPr id="20" name="Shape 14"/>
           <p:cNvSpPr/>
           <p:nvPr/>
         </p:nvSpPr>
@@ -8635,7 +8672,7 @@
       </p:sp>
       <p:sp>
         <p:nvSpPr>
-          <p:cNvPr id="20" name="Text 15"/>
+          <p:cNvPr id="21" name="Text 15"/>
           <p:cNvSpPr/>
           <p:nvPr/>
         </p:nvSpPr>
@@ -8718,16 +8755,40 @@
           <a:chExt cx="0" cy="0"/>
         </a:xfrm>
       </p:grpSpPr>
-      <p:sp>
-        <p:nvSpPr>
-          <p:cNvPr id="2" name="Text 0"/>
+      <p:pic>
+        <p:nvPicPr>
+          <p:cNvPr id="2" name="Image 0" descr="preencoded.png">    </p:cNvPr>
+          <p:cNvPicPr>
+            <a:picLocks noChangeAspect="1"/>
+          </p:cNvPicPr>
+          <p:nvPr/>
+        </p:nvPicPr>
+        <p:blipFill>
+          <a:blip r:embed="rId1"/>
+          <a:stretch>
+            <a:fillRect/>
+          </a:stretch>
+        </p:blipFill>
+        <p:spPr>
+          <a:xfrm>
+            <a:off x="9720072" y="384048"/>
+            <a:ext cx="1920240" cy="521208"/>
+          </a:xfrm>
+          <a:prstGeom prst="rect">
+            <a:avLst/>
+          </a:prstGeom>
+        </p:spPr>
+      </p:pic>
+      <p:sp>
+        <p:nvSpPr>
+          <p:cNvPr id="3" name="Text 0"/>
           <p:cNvSpPr/>
           <p:nvPr/>
         </p:nvSpPr>
         <p:spPr>
           <a:xfrm>
             <a:off x="548640" y="320040"/>
-            <a:ext cx="11064240" cy="685800"/>
+            <a:ext cx="9052560" cy="685800"/>
           </a:xfrm>
           <a:prstGeom prst="rect">
             <a:avLst/>
@@ -8759,7 +8820,7 @@
       </p:sp>
       <p:sp>
         <p:nvSpPr>
-          <p:cNvPr id="3" name="Text 1"/>
+          <p:cNvPr id="4" name="Text 1"/>
           <p:cNvSpPr/>
           <p:nvPr/>
         </p:nvSpPr>
@@ -8798,7 +8859,7 @@
       </p:sp>
       <p:sp>
         <p:nvSpPr>
-          <p:cNvPr id="4" name="Shape 2"/>
+          <p:cNvPr id="5" name="Shape 2"/>
           <p:cNvSpPr/>
           <p:nvPr/>
         </p:nvSpPr>
@@ -8827,7 +8888,7 @@
       </p:sp>
       <p:sp>
         <p:nvSpPr>
-          <p:cNvPr id="5" name="Shape 3"/>
+          <p:cNvPr id="6" name="Shape 3"/>
           <p:cNvSpPr/>
           <p:nvPr/>
         </p:nvSpPr>
@@ -8847,14 +8908,14 @@
       </p:sp>
       <p:pic>
         <p:nvPicPr>
-          <p:cNvPr id="6" name="Image 0" descr="preencoded.png">    </p:cNvPr>
+          <p:cNvPr id="7" name="Image 1" descr="preencoded.png">    </p:cNvPr>
           <p:cNvPicPr>
             <a:picLocks noChangeAspect="1"/>
           </p:cNvPicPr>
           <p:nvPr/>
         </p:nvPicPr>
         <p:blipFill>
-          <a:blip r:embed="rId1"/>
+          <a:blip r:embed="rId2"/>
           <a:stretch>
             <a:fillRect/>
           </a:stretch>
@@ -8871,7 +8932,7 @@
       </p:pic>
       <p:sp>
         <p:nvSpPr>
-          <p:cNvPr id="7" name="Text 4"/>
+          <p:cNvPr id="8" name="Text 4"/>
           <p:cNvSpPr/>
           <p:nvPr/>
         </p:nvSpPr>
@@ -8910,7 +8971,7 @@
       </p:sp>
       <p:sp>
         <p:nvSpPr>
-          <p:cNvPr id="8" name="Text 5"/>
+          <p:cNvPr id="9" name="Text 5"/>
           <p:cNvSpPr/>
           <p:nvPr/>
         </p:nvSpPr>
@@ -8949,7 +9010,7 @@
       </p:sp>
       <p:sp>
         <p:nvSpPr>
-          <p:cNvPr id="9" name="Shape 6"/>
+          <p:cNvPr id="10" name="Shape 6"/>
           <p:cNvSpPr/>
           <p:nvPr/>
         </p:nvSpPr>
@@ -8978,7 +9039,7 @@
       </p:sp>
       <p:sp>
         <p:nvSpPr>
-          <p:cNvPr id="10" name="Shape 7"/>
+          <p:cNvPr id="11" name="Shape 7"/>
           <p:cNvSpPr/>
           <p:nvPr/>
         </p:nvSpPr>
@@ -8998,14 +9059,14 @@
       </p:sp>
       <p:pic>
         <p:nvPicPr>
-          <p:cNvPr id="11" name="Image 1" descr="preencoded.png">    </p:cNvPr>
+          <p:cNvPr id="12" name="Image 2" descr="preencoded.png">    </p:cNvPr>
           <p:cNvPicPr>
             <a:picLocks noChangeAspect="1"/>
           </p:cNvPicPr>
           <p:nvPr/>
         </p:nvPicPr>
         <p:blipFill>
-          <a:blip r:embed="rId2"/>
+          <a:blip r:embed="rId3"/>
           <a:stretch>
             <a:fillRect/>
           </a:stretch>
@@ -9022,7 +9083,7 @@
       </p:pic>
       <p:sp>
         <p:nvSpPr>
-          <p:cNvPr id="12" name="Text 8"/>
+          <p:cNvPr id="13" name="Text 8"/>
           <p:cNvSpPr/>
           <p:nvPr/>
         </p:nvSpPr>
@@ -9061,7 +9122,7 @@
       </p:sp>
       <p:sp>
         <p:nvSpPr>
-          <p:cNvPr id="13" name="Text 9"/>
+          <p:cNvPr id="14" name="Text 9"/>
           <p:cNvSpPr/>
           <p:nvPr/>
         </p:nvSpPr>
@@ -9100,7 +9161,7 @@
       </p:sp>
       <p:sp>
         <p:nvSpPr>
-          <p:cNvPr id="14" name="Shape 10"/>
+          <p:cNvPr id="15" name="Shape 10"/>
           <p:cNvSpPr/>
           <p:nvPr/>
         </p:nvSpPr>
@@ -9129,7 +9190,7 @@
       </p:sp>
       <p:sp>
         <p:nvSpPr>
-          <p:cNvPr id="15" name="Shape 11"/>
+          <p:cNvPr id="16" name="Shape 11"/>
           <p:cNvSpPr/>
           <p:nvPr/>
         </p:nvSpPr>
@@ -9149,14 +9210,14 @@
       </p:sp>
       <p:pic>
         <p:nvPicPr>
-          <p:cNvPr id="16" name="Image 2" descr="preencoded.png">    </p:cNvPr>
+          <p:cNvPr id="17" name="Image 3" descr="preencoded.png">    </p:cNvPr>
           <p:cNvPicPr>
             <a:picLocks noChangeAspect="1"/>
           </p:cNvPicPr>
           <p:nvPr/>
         </p:nvPicPr>
         <p:blipFill>
-          <a:blip r:embed="rId3"/>
+          <a:blip r:embed="rId4"/>
           <a:stretch>
             <a:fillRect/>
           </a:stretch>
@@ -9173,7 +9234,7 @@
       </p:pic>
       <p:sp>
         <p:nvSpPr>
-          <p:cNvPr id="17" name="Text 12"/>
+          <p:cNvPr id="18" name="Text 12"/>
           <p:cNvSpPr/>
           <p:nvPr/>
         </p:nvSpPr>
@@ -9212,7 +9273,7 @@
       </p:sp>
       <p:sp>
         <p:nvSpPr>
-          <p:cNvPr id="18" name="Text 13"/>
+          <p:cNvPr id="19" name="Text 13"/>
           <p:cNvSpPr/>
           <p:nvPr/>
         </p:nvSpPr>
@@ -9251,7 +9312,7 @@
       </p:sp>
       <p:sp>
         <p:nvSpPr>
-          <p:cNvPr id="19" name="Shape 14"/>
+          <p:cNvPr id="20" name="Shape 14"/>
           <p:cNvSpPr/>
           <p:nvPr/>
         </p:nvSpPr>
@@ -9280,7 +9341,7 @@
       </p:sp>
       <p:sp>
         <p:nvSpPr>
-          <p:cNvPr id="20" name="Shape 15"/>
+          <p:cNvPr id="21" name="Shape 15"/>
           <p:cNvSpPr/>
           <p:nvPr/>
         </p:nvSpPr>
@@ -9300,14 +9361,14 @@
       </p:sp>
       <p:pic>
         <p:nvPicPr>
-          <p:cNvPr id="21" name="Image 3" descr="preencoded.png">    </p:cNvPr>
+          <p:cNvPr id="22" name="Image 4" descr="preencoded.png">    </p:cNvPr>
           <p:cNvPicPr>
             <a:picLocks noChangeAspect="1"/>
           </p:cNvPicPr>
           <p:nvPr/>
         </p:nvPicPr>
         <p:blipFill>
-          <a:blip r:embed="rId4"/>
+          <a:blip r:embed="rId5"/>
           <a:stretch>
             <a:fillRect/>
           </a:stretch>
@@ -9324,7 +9385,7 @@
       </p:pic>
       <p:sp>
         <p:nvSpPr>
-          <p:cNvPr id="22" name="Text 16"/>
+          <p:cNvPr id="23" name="Text 16"/>
           <p:cNvSpPr/>
           <p:nvPr/>
         </p:nvSpPr>
@@ -9363,7 +9424,7 @@
       </p:sp>
       <p:sp>
         <p:nvSpPr>
-          <p:cNvPr id="23" name="Text 17"/>
+          <p:cNvPr id="24" name="Text 17"/>
           <p:cNvSpPr/>
           <p:nvPr/>
         </p:nvSpPr>
@@ -9402,7 +9463,7 @@
       </p:sp>
       <p:sp>
         <p:nvSpPr>
-          <p:cNvPr id="24" name="Shape 18"/>
+          <p:cNvPr id="25" name="Shape 18"/>
           <p:cNvSpPr/>
           <p:nvPr/>
         </p:nvSpPr>
@@ -9431,7 +9492,7 @@
       </p:sp>
       <p:sp>
         <p:nvSpPr>
-          <p:cNvPr id="25" name="Shape 19"/>
+          <p:cNvPr id="26" name="Shape 19"/>
           <p:cNvSpPr/>
           <p:nvPr/>
         </p:nvSpPr>
@@ -9451,14 +9512,14 @@
       </p:sp>
       <p:pic>
         <p:nvPicPr>
-          <p:cNvPr id="26" name="Image 4" descr="preencoded.png">    </p:cNvPr>
+          <p:cNvPr id="27" name="Image 5" descr="preencoded.png">    </p:cNvPr>
           <p:cNvPicPr>
             <a:picLocks noChangeAspect="1"/>
           </p:cNvPicPr>
           <p:nvPr/>
         </p:nvPicPr>
         <p:blipFill>
-          <a:blip r:embed="rId5"/>
+          <a:blip r:embed="rId6"/>
           <a:stretch>
             <a:fillRect/>
           </a:stretch>
@@ -9475,7 +9536,7 @@
       </p:pic>
       <p:sp>
         <p:nvSpPr>
-          <p:cNvPr id="27" name="Text 20"/>
+          <p:cNvPr id="28" name="Text 20"/>
           <p:cNvSpPr/>
           <p:nvPr/>
         </p:nvSpPr>
@@ -9514,7 +9575,7 @@
       </p:sp>
       <p:sp>
         <p:nvSpPr>
-          <p:cNvPr id="28" name="Text 21"/>
+          <p:cNvPr id="29" name="Text 21"/>
           <p:cNvSpPr/>
           <p:nvPr/>
         </p:nvSpPr>
@@ -9553,7 +9614,7 @@
       </p:sp>
       <p:sp>
         <p:nvSpPr>
-          <p:cNvPr id="29" name="Shape 22"/>
+          <p:cNvPr id="30" name="Shape 22"/>
           <p:cNvSpPr/>
           <p:nvPr/>
         </p:nvSpPr>
@@ -9582,7 +9643,7 @@
       </p:sp>
       <p:sp>
         <p:nvSpPr>
-          <p:cNvPr id="30" name="Shape 23"/>
+          <p:cNvPr id="31" name="Shape 23"/>
           <p:cNvSpPr/>
           <p:nvPr/>
         </p:nvSpPr>
@@ -9602,14 +9663,14 @@
       </p:sp>
       <p:pic>
         <p:nvPicPr>
-          <p:cNvPr id="31" name="Image 5" descr="preencoded.png">    </p:cNvPr>
+          <p:cNvPr id="32" name="Image 6" descr="preencoded.png">    </p:cNvPr>
           <p:cNvPicPr>
             <a:picLocks noChangeAspect="1"/>
           </p:cNvPicPr>
           <p:nvPr/>
         </p:nvPicPr>
         <p:blipFill>
-          <a:blip r:embed="rId6"/>
+          <a:blip r:embed="rId7"/>
           <a:stretch>
             <a:fillRect/>
           </a:stretch>
@@ -9626,7 +9687,7 @@
       </p:pic>
       <p:sp>
         <p:nvSpPr>
-          <p:cNvPr id="32" name="Text 24"/>
+          <p:cNvPr id="33" name="Text 24"/>
           <p:cNvSpPr/>
           <p:nvPr/>
         </p:nvSpPr>
@@ -9665,7 +9726,7 @@
       </p:sp>
       <p:sp>
         <p:nvSpPr>
-          <p:cNvPr id="33" name="Text 25"/>
+          <p:cNvPr id="34" name="Text 25"/>
           <p:cNvSpPr/>
           <p:nvPr/>
         </p:nvSpPr>
@@ -9704,7 +9765,7 @@
       </p:sp>
       <p:sp>
         <p:nvSpPr>
-          <p:cNvPr id="34" name="Text 26"/>
+          <p:cNvPr id="35" name="Text 26"/>
           <p:cNvSpPr/>
           <p:nvPr/>
         </p:nvSpPr>
@@ -9773,16 +9834,40 @@
           <a:chExt cx="0" cy="0"/>
         </a:xfrm>
       </p:grpSpPr>
-      <p:sp>
-        <p:nvSpPr>
-          <p:cNvPr id="2" name="Text 0"/>
+      <p:pic>
+        <p:nvPicPr>
+          <p:cNvPr id="2" name="Image 0" descr="preencoded.png">    </p:cNvPr>
+          <p:cNvPicPr>
+            <a:picLocks noChangeAspect="1"/>
+          </p:cNvPicPr>
+          <p:nvPr/>
+        </p:nvPicPr>
+        <p:blipFill>
+          <a:blip r:embed="rId1"/>
+          <a:stretch>
+            <a:fillRect/>
+          </a:stretch>
+        </p:blipFill>
+        <p:spPr>
+          <a:xfrm>
+            <a:off x="9720072" y="384048"/>
+            <a:ext cx="1920240" cy="521208"/>
+          </a:xfrm>
+          <a:prstGeom prst="rect">
+            <a:avLst/>
+          </a:prstGeom>
+        </p:spPr>
+      </p:pic>
+      <p:sp>
+        <p:nvSpPr>
+          <p:cNvPr id="3" name="Text 0"/>
           <p:cNvSpPr/>
           <p:nvPr/>
         </p:nvSpPr>
         <p:spPr>
           <a:xfrm>
             <a:off x="548640" y="320040"/>
-            <a:ext cx="11064240" cy="685800"/>
+            <a:ext cx="9052560" cy="685800"/>
           </a:xfrm>
           <a:prstGeom prst="rect">
             <a:avLst/>
@@ -9814,7 +9899,7 @@
       </p:sp>
       <p:sp>
         <p:nvSpPr>
-          <p:cNvPr id="3" name="Text 1"/>
+          <p:cNvPr id="4" name="Text 1"/>
           <p:cNvSpPr/>
           <p:nvPr/>
         </p:nvSpPr>
@@ -9853,7 +9938,7 @@
       </p:sp>
       <p:sp>
         <p:nvSpPr>
-          <p:cNvPr id="4" name="Shape 2"/>
+          <p:cNvPr id="5" name="Shape 2"/>
           <p:cNvSpPr/>
           <p:nvPr/>
         </p:nvSpPr>
@@ -9873,7 +9958,7 @@
       </p:sp>
       <p:sp>
         <p:nvSpPr>
-          <p:cNvPr id="5" name="Shape 3"/>
+          <p:cNvPr id="6" name="Shape 3"/>
           <p:cNvSpPr/>
           <p:nvPr/>
         </p:nvSpPr>
@@ -9893,7 +9978,7 @@
       </p:sp>
       <p:sp>
         <p:nvSpPr>
-          <p:cNvPr id="6" name="Text 4"/>
+          <p:cNvPr id="7" name="Text 4"/>
           <p:cNvSpPr/>
           <p:nvPr/>
         </p:nvSpPr>
@@ -9932,7 +10017,7 @@
       </p:sp>
       <p:sp>
         <p:nvSpPr>
-          <p:cNvPr id="7" name="Text 5"/>
+          <p:cNvPr id="8" name="Text 5"/>
           <p:cNvSpPr/>
           <p:nvPr/>
         </p:nvSpPr>
@@ -9971,7 +10056,7 @@
       </p:sp>
       <p:sp>
         <p:nvSpPr>
-          <p:cNvPr id="8" name="Text 6"/>
+          <p:cNvPr id="9" name="Text 6"/>
           <p:cNvSpPr/>
           <p:nvPr/>
         </p:nvSpPr>
@@ -10010,7 +10095,7 @@
       </p:sp>
       <p:sp>
         <p:nvSpPr>
-          <p:cNvPr id="9" name="Text 7"/>
+          <p:cNvPr id="10" name="Text 7"/>
           <p:cNvSpPr/>
           <p:nvPr/>
         </p:nvSpPr>
@@ -10049,7 +10134,7 @@
       </p:sp>
       <p:sp>
         <p:nvSpPr>
-          <p:cNvPr id="10" name="Shape 8"/>
+          <p:cNvPr id="11" name="Shape 8"/>
           <p:cNvSpPr/>
           <p:nvPr/>
         </p:nvSpPr>
@@ -10069,7 +10154,7 @@
       </p:sp>
       <p:sp>
         <p:nvSpPr>
-          <p:cNvPr id="11" name="Text 9"/>
+          <p:cNvPr id="12" name="Text 9"/>
           <p:cNvSpPr/>
           <p:nvPr/>
         </p:nvSpPr>
@@ -10108,7 +10193,7 @@
       </p:sp>
       <p:sp>
         <p:nvSpPr>
-          <p:cNvPr id="12" name="Text 10"/>
+          <p:cNvPr id="13" name="Text 10"/>
           <p:cNvSpPr/>
           <p:nvPr/>
         </p:nvSpPr>
@@ -10147,7 +10232,7 @@
       </p:sp>
       <p:sp>
         <p:nvSpPr>
-          <p:cNvPr id="13" name="Text 11"/>
+          <p:cNvPr id="14" name="Text 11"/>
           <p:cNvSpPr/>
           <p:nvPr/>
         </p:nvSpPr>
@@ -10186,7 +10271,7 @@
       </p:sp>
       <p:sp>
         <p:nvSpPr>
-          <p:cNvPr id="14" name="Text 12"/>
+          <p:cNvPr id="15" name="Text 12"/>
           <p:cNvSpPr/>
           <p:nvPr/>
         </p:nvSpPr>
@@ -10225,7 +10310,7 @@
       </p:sp>
       <p:sp>
         <p:nvSpPr>
-          <p:cNvPr id="15" name="Shape 13"/>
+          <p:cNvPr id="16" name="Shape 13"/>
           <p:cNvSpPr/>
           <p:nvPr/>
         </p:nvSpPr>
@@ -10245,7 +10330,7 @@
       </p:sp>
       <p:sp>
         <p:nvSpPr>
-          <p:cNvPr id="16" name="Text 14"/>
+          <p:cNvPr id="17" name="Text 14"/>
           <p:cNvSpPr/>
           <p:nvPr/>
         </p:nvSpPr>
@@ -10284,7 +10369,7 @@
       </p:sp>
       <p:sp>
         <p:nvSpPr>
-          <p:cNvPr id="17" name="Text 15"/>
+          <p:cNvPr id="18" name="Text 15"/>
           <p:cNvSpPr/>
           <p:nvPr/>
         </p:nvSpPr>
@@ -10323,7 +10408,7 @@
       </p:sp>
       <p:sp>
         <p:nvSpPr>
-          <p:cNvPr id="18" name="Text 16"/>
+          <p:cNvPr id="19" name="Text 16"/>
           <p:cNvSpPr/>
           <p:nvPr/>
         </p:nvSpPr>
@@ -10362,7 +10447,7 @@
       </p:sp>
       <p:sp>
         <p:nvSpPr>
-          <p:cNvPr id="19" name="Text 17"/>
+          <p:cNvPr id="20" name="Text 17"/>
           <p:cNvSpPr/>
           <p:nvPr/>
         </p:nvSpPr>
@@ -10401,7 +10486,7 @@
       </p:sp>
       <p:sp>
         <p:nvSpPr>
-          <p:cNvPr id="20" name="Shape 18"/>
+          <p:cNvPr id="21" name="Shape 18"/>
           <p:cNvSpPr/>
           <p:nvPr/>
         </p:nvSpPr>
@@ -10421,7 +10506,7 @@
       </p:sp>
       <p:sp>
         <p:nvSpPr>
-          <p:cNvPr id="21" name="Text 19"/>
+          <p:cNvPr id="22" name="Text 19"/>
           <p:cNvSpPr/>
           <p:nvPr/>
         </p:nvSpPr>
@@ -10460,7 +10545,7 @@
       </p:sp>
       <p:sp>
         <p:nvSpPr>
-          <p:cNvPr id="22" name="Text 20"/>
+          <p:cNvPr id="23" name="Text 20"/>
           <p:cNvSpPr/>
           <p:nvPr/>
         </p:nvSpPr>
@@ -10499,7 +10584,7 @@
       </p:sp>
       <p:sp>
         <p:nvSpPr>
-          <p:cNvPr id="23" name="Text 21"/>
+          <p:cNvPr id="24" name="Text 21"/>
           <p:cNvSpPr/>
           <p:nvPr/>
         </p:nvSpPr>
@@ -10538,7 +10623,7 @@
       </p:sp>
       <p:sp>
         <p:nvSpPr>
-          <p:cNvPr id="24" name="Text 22"/>
+          <p:cNvPr id="25" name="Text 22"/>
           <p:cNvSpPr/>
           <p:nvPr/>
         </p:nvSpPr>
@@ -10577,7 +10662,7 @@
       </p:sp>
       <p:sp>
         <p:nvSpPr>
-          <p:cNvPr id="25" name="Shape 23"/>
+          <p:cNvPr id="26" name="Shape 23"/>
           <p:cNvSpPr/>
           <p:nvPr/>
         </p:nvSpPr>
@@ -10599,7 +10684,7 @@
       </p:sp>
       <p:sp>
         <p:nvSpPr>
-          <p:cNvPr id="26" name="Text 24"/>
+          <p:cNvPr id="27" name="Text 24"/>
           <p:cNvSpPr/>
           <p:nvPr/>
         </p:nvSpPr>

</xml_diff>